<commit_message>
docs(presentation): drop em dashes from slide copy
Replaced with periods, commas, or colons depending on context. Em dashes
in code comments left alone since they don't render in the deck.

Co-Authored-By: Claude Opus 4.6 <noreply@anthropic.com>
</commit_message>
<xml_diff>
--- a/AI_Frontier_Presentation.pptx
+++ b/AI_Frontier_Presentation.pptx
@@ -3446,7 +3446,7 @@
                 </a:solidFill>
                 <a:latin typeface="Inter"/>
               </a:rPr>
-              <a:t>Comparing 255+ AI models on cost, speed, and intelligence —</a:t>
+              <a:t>Comparing 255+ AI models on cost, speed, and intelligence,</a:t>
             </a:r>
           </a:p>
         </p:txBody>
@@ -4608,7 +4608,7 @@
                 </a:solidFill>
                 <a:latin typeface="Inter"/>
               </a:rPr>
-              <a:t>Track which models lead on what — the leaderboard shifts every few weeks.</a:t>
+              <a:t>Track which models lead on what. The leaderboard shifts every few weeks.</a:t>
             </a:r>
           </a:p>
         </p:txBody>
@@ -4994,7 +4994,7 @@
                 </a:solidFill>
                 <a:latin typeface="Inter"/>
               </a:rPr>
-              <a:t>AI Frontier puts every comparison in one place — so the answer is a glance, not a spreadsheet.</a:t>
+              <a:t>AI Frontier puts every comparison in one place, so the answer is a glance, not a spreadsheet.</a:t>
             </a:r>
           </a:p>
         </p:txBody>
@@ -5357,7 +5357,7 @@
                 </a:solidFill>
                 <a:latin typeface="Inter"/>
               </a:rPr>
-              <a:t>All numbers come from one place — the Artificial Analysis public API.</a:t>
+              <a:t>All numbers come from one place: the Artificial Analysis public API.</a:t>
             </a:r>
           </a:p>
         </p:txBody>
@@ -5571,7 +5571,7 @@
                 </a:solidFill>
                 <a:latin typeface="Inter"/>
               </a:rPr>
-              <a:t>Independent benchmarking org — used by labs and journalists alike</a:t>
+              <a:t>Independent benchmarking org used by labs and journalists alike</a:t>
             </a:r>
           </a:p>
         </p:txBody>
@@ -8157,7 +8157,7 @@
                 </a:solidFill>
                 <a:latin typeface="Inter"/>
               </a:rPr>
-              <a:t>Built end-to-end in Python — no JavaScript framework, no build step, one process.</a:t>
+              <a:t>Built end-to-end in Python. No JavaScript framework, no build step, one process.</a:t>
             </a:r>
           </a:p>
         </p:txBody>
@@ -9013,7 +9013,7 @@
                 </a:solidFill>
                 <a:latin typeface="Inter"/>
               </a:rPr>
-              <a:t>Plain HTTP call to the Artificial Analysis API every hour — no browser, no overhead.</a:t>
+              <a:t>Plain HTTP call to the Artificial Analysis API every hour. No browser, no overhead.</a:t>
             </a:r>
           </a:p>
         </p:txBody>
@@ -9055,7 +9055,7 @@
                 </a:solidFill>
                 <a:latin typeface="Inter"/>
               </a:rPr>
-              <a:t>Plus a small helper script (python-pptx) — these slides are generated from the same color tokens as the website.</a:t>
+              <a:t>Plus a small helper script (python-pptx) that generates these slides from the same color tokens as the website.</a:t>
             </a:r>
           </a:p>
         </p:txBody>
@@ -9846,7 +9846,7 @@
                 </a:solidFill>
                 <a:latin typeface="Inter"/>
               </a:rPr>
-              <a:t>One tile per provider — area = model count</a:t>
+              <a:t>One tile per provider, sized by model count</a:t>
             </a:r>
           </a:p>
         </p:txBody>
@@ -10568,7 +10568,7 @@
                 </a:solidFill>
                 <a:latin typeface="Inter"/>
               </a:rPr>
-              <a:t>Provider has both a color AND a marker shape — readable for colorblind viewers.</a:t>
+              <a:t>Provider has both a color AND a marker shape, readable for colorblind viewers.</a:t>
             </a:r>
           </a:p>
         </p:txBody>
@@ -11183,7 +11183,7 @@
                 </a:solidFill>
                 <a:latin typeface="Inter"/>
               </a:rPr>
-              <a:t>Not everything has to live on the cloud. The dashboard also tracks open-weight models you can run yourself — and recommends hybrid setups for tools like Claude Code / openclaw.</a:t>
+              <a:t>Not everything has to live on the cloud. The dashboard also tracks open-weight models you can run yourself, and recommends hybrid setups for tools like Claude Code / openclaw.</a:t>
             </a:r>
           </a:p>
         </p:txBody>

</xml_diff>

<commit_message>
docs(presentation): add Render to tools slide, split data sources
Tools slide: 4 cards -> 5, adding Render (hosting) with its own color.
Data slide: split into two source cards (AA API for cloud models vs.
manually curated catalog for local open-weight models and GPU hardware
specs from manufacturer spec sheets / HuggingFace model cards).

Co-Authored-By: Claude Opus 4.6 <noreply@anthropic.com>
</commit_message>
<xml_diff>
--- a/AI_Frontier_Presentation.pptx
+++ b/AI_Frontier_Presentation.pptx
@@ -5357,7 +5357,7 @@
                 </a:solidFill>
                 <a:latin typeface="Inter"/>
               </a:rPr>
-              <a:t>All numbers come from one place: the Artificial Analysis public API.</a:t>
+              <a:t>Two separate data sources: a live API for cloud models, and a curated catalog for local hardware.</a:t>
             </a:r>
           </a:p>
         </p:txBody>
@@ -5370,8 +5370,8 @@
         </p:nvSpPr>
         <p:spPr>
           <a:xfrm>
-            <a:off x="548640" y="2331720"/>
-            <a:ext cx="6766560" cy="3749039"/>
+            <a:off x="548640" y="2240280"/>
+            <a:ext cx="6766560" cy="2103120"/>
           </a:xfrm>
           <a:prstGeom prst="rect">
             <a:avLst/>
@@ -5408,98 +5408,14 @@
       </p:sp>
       <p:sp>
         <p:nvSpPr>
-          <p:cNvPr id="11" name="TextBox 10"/>
-          <p:cNvSpPr txBox="1"/>
-          <p:nvPr/>
-        </p:nvSpPr>
-        <p:spPr>
-          <a:xfrm>
-            <a:off x="868680" y="2606040"/>
-            <a:ext cx="6126480" cy="274320"/>
-          </a:xfrm>
-          <a:prstGeom prst="rect">
-            <a:avLst/>
-          </a:prstGeom>
-          <a:noFill/>
-        </p:spPr>
-        <p:txBody>
-          <a:bodyPr wrap="square" lIns="0" rIns="0" tIns="0" bIns="0" anchor="t">
-            <a:spAutoFit/>
-          </a:bodyPr>
-          <a:lstStyle/>
-          <a:p>
-            <a:pPr algn="l">
-              <a:spcBef>
-                <a:spcPts val="0"/>
-              </a:spcBef>
-              <a:spcAft>
-                <a:spcPts val="0"/>
-              </a:spcAft>
-            </a:pPr>
-            <a:r>
-              <a:rPr sz="900" b="1" spc="140">
-                <a:solidFill>
-                  <a:srgbClr val="00D4FF"/>
-                </a:solidFill>
-                <a:latin typeface="Inter"/>
-              </a:rPr>
-              <a:t>ARTIFICIAL ANALYSIS API</a:t>
-            </a:r>
-          </a:p>
-        </p:txBody>
-      </p:sp>
-      <p:sp>
-        <p:nvSpPr>
-          <p:cNvPr id="12" name="TextBox 11"/>
-          <p:cNvSpPr txBox="1"/>
-          <p:nvPr/>
-        </p:nvSpPr>
-        <p:spPr>
-          <a:xfrm>
-            <a:off x="868680" y="2926080"/>
-            <a:ext cx="6126480" cy="457200"/>
-          </a:xfrm>
-          <a:prstGeom prst="rect">
-            <a:avLst/>
-          </a:prstGeom>
-          <a:noFill/>
-        </p:spPr>
-        <p:txBody>
-          <a:bodyPr wrap="square" lIns="0" rIns="0" tIns="0" bIns="0" anchor="t">
-            <a:spAutoFit/>
-          </a:bodyPr>
-          <a:lstStyle/>
-          <a:p>
-            <a:pPr algn="l">
-              <a:spcBef>
-                <a:spcPts val="0"/>
-              </a:spcBef>
-              <a:spcAft>
-                <a:spcPts val="0"/>
-              </a:spcAft>
-            </a:pPr>
-            <a:r>
-              <a:rPr sz="2200" b="1">
-                <a:solidFill>
-                  <a:srgbClr val="EDEDED"/>
-                </a:solidFill>
-                <a:latin typeface="Inter"/>
-              </a:rPr>
-              <a:t>One trusted source</a:t>
-            </a:r>
-          </a:p>
-        </p:txBody>
-      </p:sp>
-      <p:sp>
-        <p:nvSpPr>
-          <p:cNvPr id="13" name="Rectangle 12"/>
+          <p:cNvPr id="11" name="Rectangle 10"/>
           <p:cNvSpPr/>
           <p:nvPr/>
         </p:nvSpPr>
         <p:spPr>
           <a:xfrm>
-            <a:off x="914400" y="3867912"/>
-            <a:ext cx="91440" cy="91440"/>
+            <a:off x="548640" y="2240280"/>
+            <a:ext cx="6766560" cy="45720"/>
           </a:xfrm>
           <a:prstGeom prst="rect">
             <a:avLst/>
@@ -5536,14 +5452,14 @@
       </p:sp>
       <p:sp>
         <p:nvSpPr>
-          <p:cNvPr id="14" name="TextBox 13"/>
-          <p:cNvSpPr txBox="1"/>
-          <p:nvPr/>
-        </p:nvSpPr>
-        <p:spPr>
-          <a:xfrm>
-            <a:off x="1143000" y="3749040"/>
-            <a:ext cx="5852160" cy="365760"/>
+          <p:cNvPr id="12" name="TextBox 11"/>
+          <p:cNvSpPr txBox="1"/>
+          <p:nvPr/>
+        </p:nvSpPr>
+        <p:spPr>
+          <a:xfrm>
+            <a:off x="868680" y="2468880"/>
+            <a:ext cx="6126480" cy="274320"/>
           </a:xfrm>
           <a:prstGeom prst="rect">
             <a:avLst/>
@@ -5565,27 +5481,69 @@
               </a:spcAft>
             </a:pPr>
             <a:r>
-              <a:rPr sz="1200" b="0">
+              <a:rPr sz="900" b="1" spc="140">
+                <a:solidFill>
+                  <a:srgbClr val="00D4FF"/>
+                </a:solidFill>
+                <a:latin typeface="Inter"/>
+              </a:rPr>
+              <a:t>ARTIFICIAL ANALYSIS API  ·  artificialanalysis.ai</a:t>
+            </a:r>
+          </a:p>
+        </p:txBody>
+      </p:sp>
+      <p:sp>
+        <p:nvSpPr>
+          <p:cNvPr id="13" name="TextBox 12"/>
+          <p:cNvSpPr txBox="1"/>
+          <p:nvPr/>
+        </p:nvSpPr>
+        <p:spPr>
+          <a:xfrm>
+            <a:off x="868680" y="2788920"/>
+            <a:ext cx="6126480" cy="365760"/>
+          </a:xfrm>
+          <a:prstGeom prst="rect">
+            <a:avLst/>
+          </a:prstGeom>
+          <a:noFill/>
+        </p:spPr>
+        <p:txBody>
+          <a:bodyPr wrap="square" lIns="0" rIns="0" tIns="0" bIns="0" anchor="t">
+            <a:spAutoFit/>
+          </a:bodyPr>
+          <a:lstStyle/>
+          <a:p>
+            <a:pPr algn="l">
+              <a:spcBef>
+                <a:spcPts val="0"/>
+              </a:spcBef>
+              <a:spcAft>
+                <a:spcPts val="0"/>
+              </a:spcAft>
+            </a:pPr>
+            <a:r>
+              <a:rPr sz="1600" b="1">
                 <a:solidFill>
                   <a:srgbClr val="EDEDED"/>
                 </a:solidFill>
                 <a:latin typeface="Inter"/>
               </a:rPr>
-              <a:t>Independent benchmarking org used by labs and journalists alike</a:t>
-            </a:r>
-          </a:p>
-        </p:txBody>
-      </p:sp>
-      <p:sp>
-        <p:nvSpPr>
-          <p:cNvPr id="15" name="Rectangle 14"/>
+              <a:t>Cloud LLMs, image gen, video gen, embeddings</a:t>
+            </a:r>
+          </a:p>
+        </p:txBody>
+      </p:sp>
+      <p:sp>
+        <p:nvSpPr>
+          <p:cNvPr id="14" name="Rectangle 13"/>
           <p:cNvSpPr/>
           <p:nvPr/>
         </p:nvSpPr>
         <p:spPr>
           <a:xfrm>
-            <a:off x="914400" y="4325112"/>
-            <a:ext cx="91440" cy="91440"/>
+            <a:off x="914400" y="3383280"/>
+            <a:ext cx="73152" cy="73152"/>
           </a:xfrm>
           <a:prstGeom prst="rect">
             <a:avLst/>
@@ -5622,14 +5580,14 @@
       </p:sp>
       <p:sp>
         <p:nvSpPr>
-          <p:cNvPr id="16" name="TextBox 15"/>
-          <p:cNvSpPr txBox="1"/>
-          <p:nvPr/>
-        </p:nvSpPr>
-        <p:spPr>
-          <a:xfrm>
-            <a:off x="1143000" y="4206240"/>
-            <a:ext cx="5852160" cy="365760"/>
+          <p:cNvPr id="15" name="TextBox 14"/>
+          <p:cNvSpPr txBox="1"/>
+          <p:nvPr/>
+        </p:nvSpPr>
+        <p:spPr>
+          <a:xfrm>
+            <a:off x="1115568" y="3291840"/>
+            <a:ext cx="5852160" cy="320040"/>
           </a:xfrm>
           <a:prstGeom prst="rect">
             <a:avLst/>
@@ -5651,27 +5609,27 @@
               </a:spcAft>
             </a:pPr>
             <a:r>
-              <a:rPr sz="1200" b="0">
-                <a:solidFill>
-                  <a:srgbClr val="EDEDED"/>
-                </a:solidFill>
-                <a:latin typeface="Inter"/>
-              </a:rPr>
-              <a:t>Tracks price, speed, latency, and quality for every public model</a:t>
-            </a:r>
-          </a:p>
-        </p:txBody>
-      </p:sp>
-      <p:sp>
-        <p:nvSpPr>
-          <p:cNvPr id="17" name="Rectangle 16"/>
+              <a:rPr sz="1100" b="0">
+                <a:solidFill>
+                  <a:srgbClr val="888888"/>
+                </a:solidFill>
+                <a:latin typeface="Inter"/>
+              </a:rPr>
+              <a:t>Price, speed, latency, context window for every public model</a:t>
+            </a:r>
+          </a:p>
+        </p:txBody>
+      </p:sp>
+      <p:sp>
+        <p:nvSpPr>
+          <p:cNvPr id="16" name="Rectangle 15"/>
           <p:cNvSpPr/>
           <p:nvPr/>
         </p:nvSpPr>
         <p:spPr>
           <a:xfrm>
-            <a:off x="914400" y="4782312"/>
-            <a:ext cx="91440" cy="91440"/>
+            <a:off x="914400" y="3767328"/>
+            <a:ext cx="73152" cy="73152"/>
           </a:xfrm>
           <a:prstGeom prst="rect">
             <a:avLst/>
@@ -5708,14 +5666,14 @@
       </p:sp>
       <p:sp>
         <p:nvSpPr>
-          <p:cNvPr id="18" name="TextBox 17"/>
-          <p:cNvSpPr txBox="1"/>
-          <p:nvPr/>
-        </p:nvSpPr>
-        <p:spPr>
-          <a:xfrm>
-            <a:off x="1143000" y="4663440"/>
-            <a:ext cx="5852160" cy="365760"/>
+          <p:cNvPr id="17" name="TextBox 16"/>
+          <p:cNvSpPr txBox="1"/>
+          <p:nvPr/>
+        </p:nvSpPr>
+        <p:spPr>
+          <a:xfrm>
+            <a:off x="1115568" y="3675888"/>
+            <a:ext cx="5852160" cy="320040"/>
           </a:xfrm>
           <a:prstGeom prst="rect">
             <a:avLst/>
@@ -5737,113 +5695,27 @@
               </a:spcAft>
             </a:pPr>
             <a:r>
-              <a:rPr sz="1200" b="0">
-                <a:solidFill>
-                  <a:srgbClr val="EDEDED"/>
-                </a:solidFill>
-                <a:latin typeface="Inter"/>
-              </a:rPr>
-              <a:t>A background scraper pulls fresh data on app start, then once an hour</a:t>
-            </a:r>
-          </a:p>
-        </p:txBody>
-      </p:sp>
-      <p:sp>
-        <p:nvSpPr>
-          <p:cNvPr id="19" name="Rectangle 18"/>
+              <a:rPr sz="1100" b="0">
+                <a:solidFill>
+                  <a:srgbClr val="888888"/>
+                </a:solidFill>
+                <a:latin typeface="Inter"/>
+              </a:rPr>
+              <a:t>Scraped hourly in the background. Each run saves a dated snapshot.</a:t>
+            </a:r>
+          </a:p>
+        </p:txBody>
+      </p:sp>
+      <p:sp>
+        <p:nvSpPr>
+          <p:cNvPr id="18" name="Rectangle 17"/>
           <p:cNvSpPr/>
           <p:nvPr/>
         </p:nvSpPr>
         <p:spPr>
           <a:xfrm>
-            <a:off x="914400" y="5239512"/>
-            <a:ext cx="91440" cy="91440"/>
-          </a:xfrm>
-          <a:prstGeom prst="rect">
-            <a:avLst/>
-          </a:prstGeom>
-          <a:solidFill>
-            <a:srgbClr val="00D4FF"/>
-          </a:solidFill>
-          <a:ln>
-            <a:noFill/>
-          </a:ln>
-          <a:effectLst/>
-        </p:spPr>
-        <p:style>
-          <a:lnRef idx="1">
-            <a:schemeClr val="accent1"/>
-          </a:lnRef>
-          <a:fillRef idx="3">
-            <a:schemeClr val="accent1"/>
-          </a:fillRef>
-          <a:effectRef idx="2">
-            <a:schemeClr val="accent1"/>
-          </a:effectRef>
-          <a:fontRef idx="minor">
-            <a:schemeClr val="lt1"/>
-          </a:fontRef>
-        </p:style>
-        <p:txBody>
-          <a:bodyPr rtlCol="0" anchor="ctr"/>
-          <a:lstStyle/>
-          <a:p>
-            <a:pPr algn="ctr"/>
-          </a:p>
-        </p:txBody>
-      </p:sp>
-      <p:sp>
-        <p:nvSpPr>
-          <p:cNvPr id="20" name="TextBox 19"/>
-          <p:cNvSpPr txBox="1"/>
-          <p:nvPr/>
-        </p:nvSpPr>
-        <p:spPr>
-          <a:xfrm>
-            <a:off x="1143000" y="5120640"/>
-            <a:ext cx="5852160" cy="365760"/>
-          </a:xfrm>
-          <a:prstGeom prst="rect">
-            <a:avLst/>
-          </a:prstGeom>
-          <a:noFill/>
-        </p:spPr>
-        <p:txBody>
-          <a:bodyPr wrap="square" lIns="0" rIns="0" tIns="0" bIns="0" anchor="t">
-            <a:spAutoFit/>
-          </a:bodyPr>
-          <a:lstStyle/>
-          <a:p>
-            <a:pPr algn="l">
-              <a:spcBef>
-                <a:spcPts val="0"/>
-              </a:spcBef>
-              <a:spcAft>
-                <a:spcPts val="0"/>
-              </a:spcAft>
-            </a:pPr>
-            <a:r>
-              <a:rPr sz="1200" b="0">
-                <a:solidFill>
-                  <a:srgbClr val="EDEDED"/>
-                </a:solidFill>
-                <a:latin typeface="Inter"/>
-              </a:rPr>
-              <a:t>Each new pull is also saved as a daily snapshot for trend tracking</a:t>
-            </a:r>
-          </a:p>
-        </p:txBody>
-      </p:sp>
-      <p:sp>
-        <p:nvSpPr>
-          <p:cNvPr id="21" name="Rectangle 20"/>
-          <p:cNvSpPr/>
-          <p:nvPr/>
-        </p:nvSpPr>
-        <p:spPr>
-          <a:xfrm>
-            <a:off x="7543800" y="2331720"/>
-            <a:ext cx="4160520" cy="3749039"/>
+            <a:off x="548640" y="4480560"/>
+            <a:ext cx="6766560" cy="1645920"/>
           </a:xfrm>
           <a:prstGeom prst="rect">
             <a:avLst/>
@@ -5880,13 +5752,357 @@
       </p:sp>
       <p:sp>
         <p:nvSpPr>
-          <p:cNvPr id="22" name="TextBox 21"/>
-          <p:cNvSpPr txBox="1"/>
-          <p:nvPr/>
-        </p:nvSpPr>
-        <p:spPr>
-          <a:xfrm>
-            <a:off x="7818120" y="2606040"/>
+          <p:cNvPr id="19" name="Rectangle 18"/>
+          <p:cNvSpPr/>
+          <p:nvPr/>
+        </p:nvSpPr>
+        <p:spPr>
+          <a:xfrm>
+            <a:off x="548640" y="4480560"/>
+            <a:ext cx="6766560" cy="45720"/>
+          </a:xfrm>
+          <a:prstGeom prst="rect">
+            <a:avLst/>
+          </a:prstGeom>
+          <a:solidFill>
+            <a:srgbClr val="C084FC"/>
+          </a:solidFill>
+          <a:ln>
+            <a:noFill/>
+          </a:ln>
+          <a:effectLst/>
+        </p:spPr>
+        <p:style>
+          <a:lnRef idx="1">
+            <a:schemeClr val="accent1"/>
+          </a:lnRef>
+          <a:fillRef idx="3">
+            <a:schemeClr val="accent1"/>
+          </a:fillRef>
+          <a:effectRef idx="2">
+            <a:schemeClr val="accent1"/>
+          </a:effectRef>
+          <a:fontRef idx="minor">
+            <a:schemeClr val="lt1"/>
+          </a:fontRef>
+        </p:style>
+        <p:txBody>
+          <a:bodyPr rtlCol="0" anchor="ctr"/>
+          <a:lstStyle/>
+          <a:p>
+            <a:pPr algn="ctr"/>
+          </a:p>
+        </p:txBody>
+      </p:sp>
+      <p:sp>
+        <p:nvSpPr>
+          <p:cNvPr id="20" name="TextBox 19"/>
+          <p:cNvSpPr txBox="1"/>
+          <p:nvPr/>
+        </p:nvSpPr>
+        <p:spPr>
+          <a:xfrm>
+            <a:off x="868680" y="4709160"/>
+            <a:ext cx="6126480" cy="274320"/>
+          </a:xfrm>
+          <a:prstGeom prst="rect">
+            <a:avLst/>
+          </a:prstGeom>
+          <a:noFill/>
+        </p:spPr>
+        <p:txBody>
+          <a:bodyPr wrap="square" lIns="0" rIns="0" tIns="0" bIns="0" anchor="t">
+            <a:spAutoFit/>
+          </a:bodyPr>
+          <a:lstStyle/>
+          <a:p>
+            <a:pPr algn="l">
+              <a:spcBef>
+                <a:spcPts val="0"/>
+              </a:spcBef>
+              <a:spcAft>
+                <a:spcPts val="0"/>
+              </a:spcAft>
+            </a:pPr>
+            <a:r>
+              <a:rPr sz="900" b="1" spc="140">
+                <a:solidFill>
+                  <a:srgbClr val="C084FC"/>
+                </a:solidFill>
+                <a:latin typeface="Inter"/>
+              </a:rPr>
+              <a:t>MANUALLY CURATED  ·  Manufacturer spec sheets + HuggingFace</a:t>
+            </a:r>
+          </a:p>
+        </p:txBody>
+      </p:sp>
+      <p:sp>
+        <p:nvSpPr>
+          <p:cNvPr id="21" name="TextBox 20"/>
+          <p:cNvSpPr txBox="1"/>
+          <p:nvPr/>
+        </p:nvSpPr>
+        <p:spPr>
+          <a:xfrm>
+            <a:off x="868680" y="5029200"/>
+            <a:ext cx="6126480" cy="365760"/>
+          </a:xfrm>
+          <a:prstGeom prst="rect">
+            <a:avLst/>
+          </a:prstGeom>
+          <a:noFill/>
+        </p:spPr>
+        <p:txBody>
+          <a:bodyPr wrap="square" lIns="0" rIns="0" tIns="0" bIns="0" anchor="t">
+            <a:spAutoFit/>
+          </a:bodyPr>
+          <a:lstStyle/>
+          <a:p>
+            <a:pPr algn="l">
+              <a:spcBef>
+                <a:spcPts val="0"/>
+              </a:spcBef>
+              <a:spcAft>
+                <a:spcPts val="0"/>
+              </a:spcAft>
+            </a:pPr>
+            <a:r>
+              <a:rPr sz="1600" b="1">
+                <a:solidFill>
+                  <a:srgbClr val="EDEDED"/>
+                </a:solidFill>
+                <a:latin typeface="Inter"/>
+              </a:rPr>
+              <a:t>Local open-weight models + GPU hardware specs</a:t>
+            </a:r>
+          </a:p>
+        </p:txBody>
+      </p:sp>
+      <p:sp>
+        <p:nvSpPr>
+          <p:cNvPr id="22" name="Rectangle 21"/>
+          <p:cNvSpPr/>
+          <p:nvPr/>
+        </p:nvSpPr>
+        <p:spPr>
+          <a:xfrm>
+            <a:off x="914400" y="5559552"/>
+            <a:ext cx="73152" cy="73152"/>
+          </a:xfrm>
+          <a:prstGeom prst="rect">
+            <a:avLst/>
+          </a:prstGeom>
+          <a:solidFill>
+            <a:srgbClr val="C084FC"/>
+          </a:solidFill>
+          <a:ln>
+            <a:noFill/>
+          </a:ln>
+          <a:effectLst/>
+        </p:spPr>
+        <p:style>
+          <a:lnRef idx="1">
+            <a:schemeClr val="accent1"/>
+          </a:lnRef>
+          <a:fillRef idx="3">
+            <a:schemeClr val="accent1"/>
+          </a:fillRef>
+          <a:effectRef idx="2">
+            <a:schemeClr val="accent1"/>
+          </a:effectRef>
+          <a:fontRef idx="minor">
+            <a:schemeClr val="lt1"/>
+          </a:fontRef>
+        </p:style>
+        <p:txBody>
+          <a:bodyPr rtlCol="0" anchor="ctr"/>
+          <a:lstStyle/>
+          <a:p>
+            <a:pPr algn="ctr"/>
+          </a:p>
+        </p:txBody>
+      </p:sp>
+      <p:sp>
+        <p:nvSpPr>
+          <p:cNvPr id="23" name="TextBox 22"/>
+          <p:cNvSpPr txBox="1"/>
+          <p:nvPr/>
+        </p:nvSpPr>
+        <p:spPr>
+          <a:xfrm>
+            <a:off x="1115568" y="5486400"/>
+            <a:ext cx="5852160" cy="292608"/>
+          </a:xfrm>
+          <a:prstGeom prst="rect">
+            <a:avLst/>
+          </a:prstGeom>
+          <a:noFill/>
+        </p:spPr>
+        <p:txBody>
+          <a:bodyPr wrap="square" lIns="0" rIns="0" tIns="0" bIns="0" anchor="t">
+            <a:spAutoFit/>
+          </a:bodyPr>
+          <a:lstStyle/>
+          <a:p>
+            <a:pPr algn="l">
+              <a:spcBef>
+                <a:spcPts val="0"/>
+              </a:spcBef>
+              <a:spcAft>
+                <a:spcPts val="0"/>
+              </a:spcAft>
+            </a:pPr>
+            <a:r>
+              <a:rPr sz="1100" b="0">
+                <a:solidFill>
+                  <a:srgbClr val="888888"/>
+                </a:solidFill>
+                <a:latin typeface="Inter"/>
+              </a:rPr>
+              <a:t>GPU VRAM and memory bandwidth from official product pages (NVIDIA, AMD, Apple, Intel)</a:t>
+            </a:r>
+          </a:p>
+        </p:txBody>
+      </p:sp>
+      <p:sp>
+        <p:nvSpPr>
+          <p:cNvPr id="24" name="Rectangle 23"/>
+          <p:cNvSpPr/>
+          <p:nvPr/>
+        </p:nvSpPr>
+        <p:spPr>
+          <a:xfrm>
+            <a:off x="914400" y="5888736"/>
+            <a:ext cx="73152" cy="73152"/>
+          </a:xfrm>
+          <a:prstGeom prst="rect">
+            <a:avLst/>
+          </a:prstGeom>
+          <a:solidFill>
+            <a:srgbClr val="C084FC"/>
+          </a:solidFill>
+          <a:ln>
+            <a:noFill/>
+          </a:ln>
+          <a:effectLst/>
+        </p:spPr>
+        <p:style>
+          <a:lnRef idx="1">
+            <a:schemeClr val="accent1"/>
+          </a:lnRef>
+          <a:fillRef idx="3">
+            <a:schemeClr val="accent1"/>
+          </a:fillRef>
+          <a:effectRef idx="2">
+            <a:schemeClr val="accent1"/>
+          </a:effectRef>
+          <a:fontRef idx="minor">
+            <a:schemeClr val="lt1"/>
+          </a:fontRef>
+        </p:style>
+        <p:txBody>
+          <a:bodyPr rtlCol="0" anchor="ctr"/>
+          <a:lstStyle/>
+          <a:p>
+            <a:pPr algn="ctr"/>
+          </a:p>
+        </p:txBody>
+      </p:sp>
+      <p:sp>
+        <p:nvSpPr>
+          <p:cNvPr id="25" name="TextBox 24"/>
+          <p:cNvSpPr txBox="1"/>
+          <p:nvPr/>
+        </p:nvSpPr>
+        <p:spPr>
+          <a:xfrm>
+            <a:off x="1115568" y="5815584"/>
+            <a:ext cx="5852160" cy="292608"/>
+          </a:xfrm>
+          <a:prstGeom prst="rect">
+            <a:avLst/>
+          </a:prstGeom>
+          <a:noFill/>
+        </p:spPr>
+        <p:txBody>
+          <a:bodyPr wrap="square" lIns="0" rIns="0" tIns="0" bIns="0" anchor="t">
+            <a:spAutoFit/>
+          </a:bodyPr>
+          <a:lstStyle/>
+          <a:p>
+            <a:pPr algn="l">
+              <a:spcBef>
+                <a:spcPts val="0"/>
+              </a:spcBef>
+              <a:spcAft>
+                <a:spcPts val="0"/>
+              </a:spcAft>
+            </a:pPr>
+            <a:r>
+              <a:rPr sz="1100" b="0">
+                <a:solidFill>
+                  <a:srgbClr val="888888"/>
+                </a:solidFill>
+                <a:latin typeface="Inter"/>
+              </a:rPr>
+              <a:t>Open-weight model catalog with parameter counts from HuggingFace model cards</a:t>
+            </a:r>
+          </a:p>
+        </p:txBody>
+      </p:sp>
+      <p:sp>
+        <p:nvSpPr>
+          <p:cNvPr id="26" name="Rectangle 25"/>
+          <p:cNvSpPr/>
+          <p:nvPr/>
+        </p:nvSpPr>
+        <p:spPr>
+          <a:xfrm>
+            <a:off x="7543800" y="2240280"/>
+            <a:ext cx="4160520" cy="3886200"/>
+          </a:xfrm>
+          <a:prstGeom prst="rect">
+            <a:avLst/>
+          </a:prstGeom>
+          <a:solidFill>
+            <a:srgbClr val="111111"/>
+          </a:solidFill>
+          <a:ln>
+            <a:noFill/>
+          </a:ln>
+          <a:effectLst/>
+        </p:spPr>
+        <p:style>
+          <a:lnRef idx="1">
+            <a:schemeClr val="accent1"/>
+          </a:lnRef>
+          <a:fillRef idx="3">
+            <a:schemeClr val="accent1"/>
+          </a:fillRef>
+          <a:effectRef idx="2">
+            <a:schemeClr val="accent1"/>
+          </a:effectRef>
+          <a:fontRef idx="minor">
+            <a:schemeClr val="lt1"/>
+          </a:fontRef>
+        </p:style>
+        <p:txBody>
+          <a:bodyPr rtlCol="0" anchor="ctr"/>
+          <a:lstStyle/>
+          <a:p>
+            <a:pPr algn="ctr"/>
+          </a:p>
+        </p:txBody>
+      </p:sp>
+      <p:sp>
+        <p:nvSpPr>
+          <p:cNvPr id="27" name="TextBox 26"/>
+          <p:cNvSpPr txBox="1"/>
+          <p:nvPr/>
+        </p:nvSpPr>
+        <p:spPr>
+          <a:xfrm>
+            <a:off x="7818120" y="2514600"/>
             <a:ext cx="3611880" cy="274320"/>
           </a:xfrm>
           <a:prstGeom prst="rect">
@@ -5922,13 +6138,13 @@
       </p:sp>
       <p:sp>
         <p:nvSpPr>
-          <p:cNvPr id="23" name="TextBox 22"/>
-          <p:cNvSpPr txBox="1"/>
-          <p:nvPr/>
-        </p:nvSpPr>
-        <p:spPr>
-          <a:xfrm>
-            <a:off x="7818120" y="2971800"/>
+          <p:cNvPr id="28" name="TextBox 27"/>
+          <p:cNvSpPr txBox="1"/>
+          <p:nvPr/>
+        </p:nvSpPr>
+        <p:spPr>
+          <a:xfrm>
+            <a:off x="7818120" y="2880360"/>
             <a:ext cx="3611880" cy="640080"/>
           </a:xfrm>
           <a:prstGeom prst="rect">
@@ -5964,13 +6180,13 @@
       </p:sp>
       <p:sp>
         <p:nvSpPr>
-          <p:cNvPr id="24" name="TextBox 23"/>
-          <p:cNvSpPr txBox="1"/>
-          <p:nvPr/>
-        </p:nvSpPr>
-        <p:spPr>
-          <a:xfrm>
-            <a:off x="7818120" y="3749040"/>
+          <p:cNvPr id="29" name="TextBox 28"/>
+          <p:cNvSpPr txBox="1"/>
+          <p:nvPr/>
+        </p:nvSpPr>
+        <p:spPr>
+          <a:xfrm>
+            <a:off x="7818120" y="3657600"/>
             <a:ext cx="3611880" cy="274320"/>
           </a:xfrm>
           <a:prstGeom prst="rect">
@@ -5999,20 +6215,20 @@
                 </a:solidFill>
                 <a:latin typeface="Inter"/>
               </a:rPr>
-              <a:t>Refresh interval</a:t>
+              <a:t>Cloud model refresh interval</a:t>
             </a:r>
           </a:p>
         </p:txBody>
       </p:sp>
       <p:cxnSp>
         <p:nvCxnSpPr>
-          <p:cNvPr id="25" name="Connector 24"/>
+          <p:cNvPr id="30" name="Connector 29"/>
           <p:cNvCxnSpPr/>
           <p:nvPr/>
         </p:nvCxnSpPr>
         <p:spPr>
           <a:xfrm>
-            <a:off x="7818120" y="4160520"/>
+            <a:off x="7818120" y="4114799"/>
             <a:ext cx="3611880" cy="0"/>
           </a:xfrm>
           <a:prstGeom prst="line">
@@ -6041,13 +6257,13 @@
       </p:cxnSp>
       <p:sp>
         <p:nvSpPr>
-          <p:cNvPr id="26" name="TextBox 25"/>
-          <p:cNvSpPr txBox="1"/>
-          <p:nvPr/>
-        </p:nvSpPr>
-        <p:spPr>
-          <a:xfrm>
-            <a:off x="7818120" y="4297680"/>
+          <p:cNvPr id="31" name="TextBox 30"/>
+          <p:cNvSpPr txBox="1"/>
+          <p:nvPr/>
+        </p:nvSpPr>
+        <p:spPr>
+          <a:xfrm>
+            <a:off x="7818120" y="4251960"/>
             <a:ext cx="3611880" cy="640080"/>
           </a:xfrm>
           <a:prstGeom prst="rect">
@@ -6083,13 +6299,13 @@
       </p:sp>
       <p:sp>
         <p:nvSpPr>
-          <p:cNvPr id="27" name="TextBox 26"/>
-          <p:cNvSpPr txBox="1"/>
-          <p:nvPr/>
-        </p:nvSpPr>
-        <p:spPr>
-          <a:xfrm>
-            <a:off x="7818120" y="5074920"/>
+          <p:cNvPr id="32" name="TextBox 31"/>
+          <p:cNvSpPr txBox="1"/>
+          <p:nvPr/>
+        </p:nvSpPr>
+        <p:spPr>
+          <a:xfrm>
+            <a:off x="7818120" y="5029200"/>
             <a:ext cx="3611880" cy="274320"/>
           </a:xfrm>
           <a:prstGeom prst="rect">
@@ -6125,13 +6341,13 @@
       </p:sp>
       <p:cxnSp>
         <p:nvCxnSpPr>
-          <p:cNvPr id="28" name="Connector 27"/>
+          <p:cNvPr id="33" name="Connector 32"/>
           <p:cNvCxnSpPr/>
           <p:nvPr/>
         </p:nvCxnSpPr>
         <p:spPr>
           <a:xfrm>
-            <a:off x="7818120" y="5440680"/>
+            <a:off x="7818120" y="5394960"/>
             <a:ext cx="3611880" cy="0"/>
           </a:xfrm>
           <a:prstGeom prst="line">
@@ -6160,13 +6376,13 @@
       </p:cxnSp>
       <p:sp>
         <p:nvSpPr>
-          <p:cNvPr id="29" name="TextBox 28"/>
-          <p:cNvSpPr txBox="1"/>
-          <p:nvPr/>
-        </p:nvSpPr>
-        <p:spPr>
-          <a:xfrm>
-            <a:off x="7818120" y="5577840"/>
+          <p:cNvPr id="34" name="TextBox 33"/>
+          <p:cNvSpPr txBox="1"/>
+          <p:nvPr/>
+        </p:nvSpPr>
+        <p:spPr>
+          <a:xfrm>
+            <a:off x="7818120" y="5532120"/>
             <a:ext cx="3611880" cy="274320"/>
           </a:xfrm>
           <a:prstGeom prst="rect">
@@ -6195,20 +6411,20 @@
                 </a:solidFill>
                 <a:latin typeface="Inter"/>
               </a:rPr>
-              <a:t>LATEST PULL</a:t>
-            </a:r>
-          </a:p>
-        </p:txBody>
-      </p:sp>
-      <p:sp>
-        <p:nvSpPr>
-          <p:cNvPr id="30" name="TextBox 29"/>
-          <p:cNvSpPr txBox="1"/>
-          <p:nvPr/>
-        </p:nvSpPr>
-        <p:spPr>
-          <a:xfrm>
-            <a:off x="7818120" y="5760720"/>
+              <a:t>LOCAL CATALOG</a:t>
+            </a:r>
+          </a:p>
+        </p:txBody>
+      </p:sp>
+      <p:sp>
+        <p:nvSpPr>
+          <p:cNvPr id="35" name="TextBox 34"/>
+          <p:cNvSpPr txBox="1"/>
+          <p:nvPr/>
+        </p:nvSpPr>
+        <p:spPr>
+          <a:xfrm>
+            <a:off x="7818120" y="5733288"/>
             <a:ext cx="3611880" cy="274320"/>
           </a:xfrm>
           <a:prstGeom prst="rect">
@@ -6237,7 +6453,7 @@
                 </a:solidFill>
                 <a:latin typeface="Inter"/>
               </a:rPr>
-              <a:t>Today  ·  255+ models, 29 providers</a:t>
+              <a:t>Static  ·  updated when new models release</a:t>
             </a:r>
           </a:p>
         </p:txBody>
@@ -8157,7 +8373,7 @@
                 </a:solidFill>
                 <a:latin typeface="Inter"/>
               </a:rPr>
-              <a:t>Built end-to-end in Python. No JavaScript framework, no build step, one process.</a:t>
+              <a:t>Built in Python, hosted on Render. No JavaScript, no build step.</a:t>
             </a:r>
           </a:p>
         </p:txBody>
@@ -8170,8 +8386,8 @@
         </p:nvSpPr>
         <p:spPr>
           <a:xfrm>
-            <a:off x="548640" y="2377440"/>
-            <a:ext cx="2636443" cy="3291840"/>
+            <a:off x="548640" y="2331720"/>
+            <a:ext cx="2101839" cy="3291840"/>
           </a:xfrm>
           <a:prstGeom prst="rect">
             <a:avLst/>
@@ -8214,8 +8430,8 @@
         </p:nvSpPr>
         <p:spPr>
           <a:xfrm>
-            <a:off x="548640" y="2377440"/>
-            <a:ext cx="2636443" cy="45720"/>
+            <a:off x="548640" y="2331720"/>
+            <a:ext cx="2101839" cy="45720"/>
           </a:xfrm>
           <a:prstGeom prst="rect">
             <a:avLst/>
@@ -8258,8 +8474,8 @@
         </p:nvSpPr>
         <p:spPr>
           <a:xfrm>
-            <a:off x="822960" y="2743200"/>
-            <a:ext cx="2087803" cy="548640"/>
+            <a:off x="777240" y="2651760"/>
+            <a:ext cx="1644639" cy="548640"/>
           </a:xfrm>
           <a:prstGeom prst="rect">
             <a:avLst/>
@@ -8281,7 +8497,7 @@
               </a:spcAft>
             </a:pPr>
             <a:r>
-              <a:rPr sz="2400" b="1">
+              <a:rPr sz="2000" b="1">
                 <a:solidFill>
                   <a:srgbClr val="EDEDED"/>
                 </a:solidFill>
@@ -8300,8 +8516,8 @@
         </p:nvSpPr>
         <p:spPr>
           <a:xfrm>
-            <a:off x="822960" y="3337560"/>
-            <a:ext cx="2087803" cy="274320"/>
+            <a:off x="777240" y="3200400"/>
+            <a:ext cx="1644639" cy="274320"/>
           </a:xfrm>
           <a:prstGeom prst="rect">
             <a:avLst/>
@@ -8323,7 +8539,7 @@
               </a:spcAft>
             </a:pPr>
             <a:r>
-              <a:rPr sz="900" b="1" spc="140">
+              <a:rPr sz="800" b="1" spc="140">
                 <a:solidFill>
                   <a:srgbClr val="00D4FF"/>
                 </a:solidFill>
@@ -8342,8 +8558,8 @@
         </p:nvSpPr>
         <p:spPr>
           <a:xfrm>
-            <a:off x="822960" y="3749040"/>
-            <a:ext cx="2087803" cy="1828800"/>
+            <a:off x="777240" y="3566160"/>
+            <a:ext cx="1644639" cy="1920240"/>
           </a:xfrm>
           <a:prstGeom prst="rect">
             <a:avLst/>
@@ -8365,13 +8581,13 @@
               </a:spcAft>
             </a:pPr>
             <a:r>
-              <a:rPr sz="1200" b="0">
+              <a:rPr sz="1100" b="0">
                 <a:solidFill>
                   <a:srgbClr val="888888"/>
                 </a:solidFill>
                 <a:latin typeface="Inter"/>
               </a:rPr>
-              <a:t>Turns Python functions into a live, interactive site. Handles tabs, filters, and updates.</a:t>
+              <a:t>Turns Python functions into a live interactive site. Handles tabs, filters, and callbacks.</a:t>
             </a:r>
           </a:p>
         </p:txBody>
@@ -8384,8 +8600,8 @@
         </p:nvSpPr>
         <p:spPr>
           <a:xfrm>
-            <a:off x="3367963" y="2377440"/>
-            <a:ext cx="2636443" cy="3291840"/>
+            <a:off x="2796783" y="2331720"/>
+            <a:ext cx="2101839" cy="3291840"/>
           </a:xfrm>
           <a:prstGeom prst="rect">
             <a:avLst/>
@@ -8428,8 +8644,8 @@
         </p:nvSpPr>
         <p:spPr>
           <a:xfrm>
-            <a:off x="3367963" y="2377440"/>
-            <a:ext cx="2636443" cy="45720"/>
+            <a:off x="2796783" y="2331720"/>
+            <a:ext cx="2101839" cy="45720"/>
           </a:xfrm>
           <a:prstGeom prst="rect">
             <a:avLst/>
@@ -8472,8 +8688,8 @@
         </p:nvSpPr>
         <p:spPr>
           <a:xfrm>
-            <a:off x="3642283" y="2743200"/>
-            <a:ext cx="2087803" cy="548640"/>
+            <a:off x="3025383" y="2651760"/>
+            <a:ext cx="1644639" cy="548640"/>
           </a:xfrm>
           <a:prstGeom prst="rect">
             <a:avLst/>
@@ -8495,7 +8711,7 @@
               </a:spcAft>
             </a:pPr>
             <a:r>
-              <a:rPr sz="2400" b="1">
+              <a:rPr sz="2000" b="1">
                 <a:solidFill>
                   <a:srgbClr val="EDEDED"/>
                 </a:solidFill>
@@ -8514,8 +8730,8 @@
         </p:nvSpPr>
         <p:spPr>
           <a:xfrm>
-            <a:off x="3642283" y="3337560"/>
-            <a:ext cx="2087803" cy="274320"/>
+            <a:off x="3025383" y="3200400"/>
+            <a:ext cx="1644639" cy="274320"/>
           </a:xfrm>
           <a:prstGeom prst="rect">
             <a:avLst/>
@@ -8537,7 +8753,7 @@
               </a:spcAft>
             </a:pPr>
             <a:r>
-              <a:rPr sz="900" b="1" spc="140">
+              <a:rPr sz="800" b="1" spc="140">
                 <a:solidFill>
                   <a:srgbClr val="C084FC"/>
                 </a:solidFill>
@@ -8556,8 +8772,8 @@
         </p:nvSpPr>
         <p:spPr>
           <a:xfrm>
-            <a:off x="3642283" y="3749040"/>
-            <a:ext cx="2087803" cy="1828800"/>
+            <a:off x="3025383" y="3566160"/>
+            <a:ext cx="1644639" cy="1920240"/>
           </a:xfrm>
           <a:prstGeom prst="rect">
             <a:avLst/>
@@ -8579,13 +8795,13 @@
               </a:spcAft>
             </a:pPr>
             <a:r>
-              <a:rPr sz="1200" b="0">
+              <a:rPr sz="1100" b="0">
                 <a:solidFill>
                   <a:srgbClr val="888888"/>
                 </a:solidFill>
                 <a:latin typeface="Inter"/>
               </a:rPr>
-              <a:t>Every chart in the dashboard. Interactive, hoverable, and themeable from one config.</a:t>
+              <a:t>Every chart in the dashboard. Interactive, hoverable, and styled from one config.</a:t>
             </a:r>
           </a:p>
         </p:txBody>
@@ -8598,8 +8814,8 @@
         </p:nvSpPr>
         <p:spPr>
           <a:xfrm>
-            <a:off x="6187287" y="2377440"/>
-            <a:ext cx="2636443" cy="3291840"/>
+            <a:off x="5044927" y="2331720"/>
+            <a:ext cx="2101839" cy="3291840"/>
           </a:xfrm>
           <a:prstGeom prst="rect">
             <a:avLst/>
@@ -8642,8 +8858,8 @@
         </p:nvSpPr>
         <p:spPr>
           <a:xfrm>
-            <a:off x="6187287" y="2377440"/>
-            <a:ext cx="2636443" cy="45720"/>
+            <a:off x="5044927" y="2331720"/>
+            <a:ext cx="2101839" cy="45720"/>
           </a:xfrm>
           <a:prstGeom prst="rect">
             <a:avLst/>
@@ -8686,8 +8902,8 @@
         </p:nvSpPr>
         <p:spPr>
           <a:xfrm>
-            <a:off x="6461607" y="2743200"/>
-            <a:ext cx="2087803" cy="548640"/>
+            <a:off x="5273527" y="2651760"/>
+            <a:ext cx="1644639" cy="548640"/>
           </a:xfrm>
           <a:prstGeom prst="rect">
             <a:avLst/>
@@ -8709,7 +8925,7 @@
               </a:spcAft>
             </a:pPr>
             <a:r>
-              <a:rPr sz="2400" b="1">
+              <a:rPr sz="2000" b="1">
                 <a:solidFill>
                   <a:srgbClr val="EDEDED"/>
                 </a:solidFill>
@@ -8728,8 +8944,8 @@
         </p:nvSpPr>
         <p:spPr>
           <a:xfrm>
-            <a:off x="6461607" y="3337560"/>
-            <a:ext cx="2087803" cy="274320"/>
+            <a:off x="5273527" y="3200400"/>
+            <a:ext cx="1644639" cy="274320"/>
           </a:xfrm>
           <a:prstGeom prst="rect">
             <a:avLst/>
@@ -8751,7 +8967,7 @@
               </a:spcAft>
             </a:pPr>
             <a:r>
-              <a:rPr sz="900" b="1" spc="140">
+              <a:rPr sz="800" b="1" spc="140">
                 <a:solidFill>
                   <a:srgbClr val="22C55E"/>
                 </a:solidFill>
@@ -8770,8 +8986,8 @@
         </p:nvSpPr>
         <p:spPr>
           <a:xfrm>
-            <a:off x="6461607" y="3749040"/>
-            <a:ext cx="2087803" cy="1828800"/>
+            <a:off x="5273527" y="3566160"/>
+            <a:ext cx="1644639" cy="1920240"/>
           </a:xfrm>
           <a:prstGeom prst="rect">
             <a:avLst/>
@@ -8793,13 +9009,13 @@
               </a:spcAft>
             </a:pPr>
             <a:r>
-              <a:rPr sz="1200" b="0">
+              <a:rPr sz="1100" b="0">
                 <a:solidFill>
                   <a:srgbClr val="888888"/>
                 </a:solidFill>
                 <a:latin typeface="Inter"/>
               </a:rPr>
-              <a:t>Loads the cached CSV, runs filters, and computes the Pareto frontier and value scores.</a:t>
+              <a:t>Loads the CSV, runs filters, and computes the Pareto frontier and value scores.</a:t>
             </a:r>
           </a:p>
         </p:txBody>
@@ -8812,8 +9028,8 @@
         </p:nvSpPr>
         <p:spPr>
           <a:xfrm>
-            <a:off x="9006611" y="2377440"/>
-            <a:ext cx="2636443" cy="3291840"/>
+            <a:off x="7293071" y="2331720"/>
+            <a:ext cx="2101839" cy="3291840"/>
           </a:xfrm>
           <a:prstGeom prst="rect">
             <a:avLst/>
@@ -8856,8 +9072,8 @@
         </p:nvSpPr>
         <p:spPr>
           <a:xfrm>
-            <a:off x="9006611" y="2377440"/>
-            <a:ext cx="2636443" cy="45720"/>
+            <a:off x="7293071" y="2331720"/>
+            <a:ext cx="2101839" cy="45720"/>
           </a:xfrm>
           <a:prstGeom prst="rect">
             <a:avLst/>
@@ -8900,8 +9116,8 @@
         </p:nvSpPr>
         <p:spPr>
           <a:xfrm>
-            <a:off x="9280931" y="2743200"/>
-            <a:ext cx="2087803" cy="548640"/>
+            <a:off x="7521671" y="2651760"/>
+            <a:ext cx="1644639" cy="548640"/>
           </a:xfrm>
           <a:prstGeom prst="rect">
             <a:avLst/>
@@ -8923,7 +9139,7 @@
               </a:spcAft>
             </a:pPr>
             <a:r>
-              <a:rPr sz="2400" b="1">
+              <a:rPr sz="2000" b="1">
                 <a:solidFill>
                   <a:srgbClr val="EDEDED"/>
                 </a:solidFill>
@@ -8942,8 +9158,8 @@
         </p:nvSpPr>
         <p:spPr>
           <a:xfrm>
-            <a:off x="9280931" y="3337560"/>
-            <a:ext cx="2087803" cy="274320"/>
+            <a:off x="7521671" y="3200400"/>
+            <a:ext cx="1644639" cy="274320"/>
           </a:xfrm>
           <a:prstGeom prst="rect">
             <a:avLst/>
@@ -8965,7 +9181,7 @@
               </a:spcAft>
             </a:pPr>
             <a:r>
-              <a:rPr sz="900" b="1" spc="140">
+              <a:rPr sz="800" b="1" spc="140">
                 <a:solidFill>
                   <a:srgbClr val="FB923C"/>
                 </a:solidFill>
@@ -8984,8 +9200,8 @@
         </p:nvSpPr>
         <p:spPr>
           <a:xfrm>
-            <a:off x="9280931" y="3749040"/>
-            <a:ext cx="2087803" cy="1828800"/>
+            <a:off x="7521671" y="3566160"/>
+            <a:ext cx="1644639" cy="1920240"/>
           </a:xfrm>
           <a:prstGeom prst="rect">
             <a:avLst/>
@@ -9007,27 +9223,115 @@
               </a:spcAft>
             </a:pPr>
             <a:r>
-              <a:rPr sz="1200" b="0">
+              <a:rPr sz="1100" b="0">
                 <a:solidFill>
                   <a:srgbClr val="888888"/>
                 </a:solidFill>
                 <a:latin typeface="Inter"/>
               </a:rPr>
-              <a:t>Plain HTTP call to the Artificial Analysis API every hour. No browser, no overhead.</a:t>
-            </a:r>
-          </a:p>
-        </p:txBody>
-      </p:sp>
-      <p:sp>
-        <p:nvSpPr>
-          <p:cNvPr id="30" name="TextBox 29"/>
-          <p:cNvSpPr txBox="1"/>
-          <p:nvPr/>
-        </p:nvSpPr>
-        <p:spPr>
-          <a:xfrm>
-            <a:off x="548640" y="5943600"/>
-            <a:ext cx="10972800" cy="274320"/>
+              <a:t>Plain HTTP call to the Artificial Analysis API every hour. No browser needed.</a:t>
+            </a:r>
+          </a:p>
+        </p:txBody>
+      </p:sp>
+      <p:sp>
+        <p:nvSpPr>
+          <p:cNvPr id="30" name="Rectangle 29"/>
+          <p:cNvSpPr/>
+          <p:nvPr/>
+        </p:nvSpPr>
+        <p:spPr>
+          <a:xfrm>
+            <a:off x="9541215" y="2331720"/>
+            <a:ext cx="2101839" cy="3291840"/>
+          </a:xfrm>
+          <a:prstGeom prst="rect">
+            <a:avLst/>
+          </a:prstGeom>
+          <a:solidFill>
+            <a:srgbClr val="111111"/>
+          </a:solidFill>
+          <a:ln>
+            <a:noFill/>
+          </a:ln>
+          <a:effectLst/>
+        </p:spPr>
+        <p:style>
+          <a:lnRef idx="1">
+            <a:schemeClr val="accent1"/>
+          </a:lnRef>
+          <a:fillRef idx="3">
+            <a:schemeClr val="accent1"/>
+          </a:fillRef>
+          <a:effectRef idx="2">
+            <a:schemeClr val="accent1"/>
+          </a:effectRef>
+          <a:fontRef idx="minor">
+            <a:schemeClr val="lt1"/>
+          </a:fontRef>
+        </p:style>
+        <p:txBody>
+          <a:bodyPr rtlCol="0" anchor="ctr"/>
+          <a:lstStyle/>
+          <a:p>
+            <a:pPr algn="ctr"/>
+          </a:p>
+        </p:txBody>
+      </p:sp>
+      <p:sp>
+        <p:nvSpPr>
+          <p:cNvPr id="31" name="Rectangle 30"/>
+          <p:cNvSpPr/>
+          <p:nvPr/>
+        </p:nvSpPr>
+        <p:spPr>
+          <a:xfrm>
+            <a:off x="9541215" y="2331720"/>
+            <a:ext cx="2101839" cy="45720"/>
+          </a:xfrm>
+          <a:prstGeom prst="rect">
+            <a:avLst/>
+          </a:prstGeom>
+          <a:solidFill>
+            <a:srgbClr val="7C3AED"/>
+          </a:solidFill>
+          <a:ln>
+            <a:noFill/>
+          </a:ln>
+          <a:effectLst/>
+        </p:spPr>
+        <p:style>
+          <a:lnRef idx="1">
+            <a:schemeClr val="accent1"/>
+          </a:lnRef>
+          <a:fillRef idx="3">
+            <a:schemeClr val="accent1"/>
+          </a:fillRef>
+          <a:effectRef idx="2">
+            <a:schemeClr val="accent1"/>
+          </a:effectRef>
+          <a:fontRef idx="minor">
+            <a:schemeClr val="lt1"/>
+          </a:fontRef>
+        </p:style>
+        <p:txBody>
+          <a:bodyPr rtlCol="0" anchor="ctr"/>
+          <a:lstStyle/>
+          <a:p>
+            <a:pPr algn="ctr"/>
+          </a:p>
+        </p:txBody>
+      </p:sp>
+      <p:sp>
+        <p:nvSpPr>
+          <p:cNvPr id="32" name="TextBox 31"/>
+          <p:cNvSpPr txBox="1"/>
+          <p:nvPr/>
+        </p:nvSpPr>
+        <p:spPr>
+          <a:xfrm>
+            <a:off x="9769815" y="2651760"/>
+            <a:ext cx="1644639" cy="548640"/>
           </a:xfrm>
           <a:prstGeom prst="rect">
             <a:avLst/>
@@ -9049,13 +9353,97 @@
               </a:spcAft>
             </a:pPr>
             <a:r>
-              <a:rPr sz="1000" b="0">
-                <a:solidFill>
-                  <a:srgbClr val="666666"/>
-                </a:solidFill>
-                <a:latin typeface="Inter"/>
-              </a:rPr>
-              <a:t>Plus a small helper script (python-pptx) that generates these slides from the same color tokens as the website.</a:t>
+              <a:rPr sz="2000" b="1">
+                <a:solidFill>
+                  <a:srgbClr val="EDEDED"/>
+                </a:solidFill>
+                <a:latin typeface="Inter"/>
+              </a:rPr>
+              <a:t>Render</a:t>
+            </a:r>
+          </a:p>
+        </p:txBody>
+      </p:sp>
+      <p:sp>
+        <p:nvSpPr>
+          <p:cNvPr id="33" name="TextBox 32"/>
+          <p:cNvSpPr txBox="1"/>
+          <p:nvPr/>
+        </p:nvSpPr>
+        <p:spPr>
+          <a:xfrm>
+            <a:off x="9769815" y="3200400"/>
+            <a:ext cx="1644639" cy="274320"/>
+          </a:xfrm>
+          <a:prstGeom prst="rect">
+            <a:avLst/>
+          </a:prstGeom>
+          <a:noFill/>
+        </p:spPr>
+        <p:txBody>
+          <a:bodyPr wrap="square" lIns="0" rIns="0" tIns="0" bIns="0" anchor="t">
+            <a:spAutoFit/>
+          </a:bodyPr>
+          <a:lstStyle/>
+          <a:p>
+            <a:pPr algn="l">
+              <a:spcBef>
+                <a:spcPts val="0"/>
+              </a:spcBef>
+              <a:spcAft>
+                <a:spcPts val="0"/>
+              </a:spcAft>
+            </a:pPr>
+            <a:r>
+              <a:rPr sz="800" b="1" spc="140">
+                <a:solidFill>
+                  <a:srgbClr val="7C3AED"/>
+                </a:solidFill>
+                <a:latin typeface="Inter"/>
+              </a:rPr>
+              <a:t>HOSTING</a:t>
+            </a:r>
+          </a:p>
+        </p:txBody>
+      </p:sp>
+      <p:sp>
+        <p:nvSpPr>
+          <p:cNvPr id="34" name="TextBox 33"/>
+          <p:cNvSpPr txBox="1"/>
+          <p:nvPr/>
+        </p:nvSpPr>
+        <p:spPr>
+          <a:xfrm>
+            <a:off x="9769815" y="3566160"/>
+            <a:ext cx="1644639" cy="1920240"/>
+          </a:xfrm>
+          <a:prstGeom prst="rect">
+            <a:avLst/>
+          </a:prstGeom>
+          <a:noFill/>
+        </p:spPr>
+        <p:txBody>
+          <a:bodyPr wrap="square" lIns="0" rIns="0" tIns="0" bIns="0" anchor="t">
+            <a:spAutoFit/>
+          </a:bodyPr>
+          <a:lstStyle/>
+          <a:p>
+            <a:pPr algn="l">
+              <a:spcBef>
+                <a:spcPts val="0"/>
+              </a:spcBef>
+              <a:spcAft>
+                <a:spcPts val="0"/>
+              </a:spcAft>
+            </a:pPr>
+            <a:r>
+              <a:rPr sz="1100" b="0">
+                <a:solidFill>
+                  <a:srgbClr val="888888"/>
+                </a:solidFill>
+                <a:latin typeface="Inter"/>
+              </a:rPr>
+              <a:t>Cloud platform that runs the app 24/7 from the GitHub repo. Redeploys on every push.</a:t>
             </a:r>
           </a:p>
         </p:txBody>

</xml_diff>

<commit_message>
docs(presentation): bigger cards and text, remove bottom taglines
Slide 2: remove bottom filler sentence, cards taller (3.0->4.0in),
body text 12->14pt. Slide 4: cards taller, desc 13->15pt, trim bottom
note to one line. Slide 5: cards taller (3.6->4.1in), name 20->22pt,
body 11->12pt. Slide 6: chart type names 13->15pt, desc 10->12pt,
principles title 13->15pt, body 10->12pt.

Co-Authored-By: Claude Opus 4.6 <noreply@anthropic.com>
</commit_message>
<xml_diff>
--- a/AI_Frontier_Presentation.pptx
+++ b/AI_Frontier_Presentation.pptx
@@ -4277,8 +4277,8 @@
         </p:nvSpPr>
         <p:spPr>
           <a:xfrm>
-            <a:off x="548640" y="2606040"/>
-            <a:ext cx="2650159" cy="2743200"/>
+            <a:off x="548640" y="2377440"/>
+            <a:ext cx="2650159" cy="3657600"/>
           </a:xfrm>
           <a:prstGeom prst="rect">
             <a:avLst/>
@@ -4321,7 +4321,7 @@
         </p:nvSpPr>
         <p:spPr>
           <a:xfrm>
-            <a:off x="548640" y="2606040"/>
+            <a:off x="548640" y="2377440"/>
             <a:ext cx="2650159" cy="45720"/>
           </a:xfrm>
           <a:prstGeom prst="rect">
@@ -4365,8 +4365,8 @@
         </p:nvSpPr>
         <p:spPr>
           <a:xfrm>
-            <a:off x="777240" y="2880360"/>
-            <a:ext cx="2192959" cy="365760"/>
+            <a:off x="822960" y="2697480"/>
+            <a:ext cx="2101519" cy="365760"/>
           </a:xfrm>
           <a:prstGeom prst="rect">
             <a:avLst/>
@@ -4388,7 +4388,7 @@
               </a:spcAft>
             </a:pPr>
             <a:r>
-              <a:rPr sz="1000" b="1" spc="160">
+              <a:rPr sz="1100" b="1" spc="160">
                 <a:solidFill>
                   <a:srgbClr val="00D4FF"/>
                 </a:solidFill>
@@ -4407,8 +4407,8 @@
         </p:nvSpPr>
         <p:spPr>
           <a:xfrm>
-            <a:off x="777240" y="3383280"/>
-            <a:ext cx="2192959" cy="1828800"/>
+            <a:off x="822960" y="3246120"/>
+            <a:ext cx="2101519" cy="2651760"/>
           </a:xfrm>
           <a:prstGeom prst="rect">
             <a:avLst/>
@@ -4430,7 +4430,7 @@
               </a:spcAft>
             </a:pPr>
             <a:r>
-              <a:rPr sz="1200" b="0">
+              <a:rPr sz="1400" b="0">
                 <a:solidFill>
                   <a:srgbClr val="EDEDED"/>
                 </a:solidFill>
@@ -4449,8 +4449,8 @@
         </p:nvSpPr>
         <p:spPr>
           <a:xfrm>
-            <a:off x="3363391" y="2606040"/>
-            <a:ext cx="2650159" cy="2743200"/>
+            <a:off x="3363391" y="2377440"/>
+            <a:ext cx="2650159" cy="3657600"/>
           </a:xfrm>
           <a:prstGeom prst="rect">
             <a:avLst/>
@@ -4493,7 +4493,7 @@
         </p:nvSpPr>
         <p:spPr>
           <a:xfrm>
-            <a:off x="3363391" y="2606040"/>
+            <a:off x="3363391" y="2377440"/>
             <a:ext cx="2650159" cy="45720"/>
           </a:xfrm>
           <a:prstGeom prst="rect">
@@ -4537,8 +4537,8 @@
         </p:nvSpPr>
         <p:spPr>
           <a:xfrm>
-            <a:off x="3591991" y="2880360"/>
-            <a:ext cx="2192959" cy="365760"/>
+            <a:off x="3637711" y="2697480"/>
+            <a:ext cx="2101519" cy="365760"/>
           </a:xfrm>
           <a:prstGeom prst="rect">
             <a:avLst/>
@@ -4560,7 +4560,7 @@
               </a:spcAft>
             </a:pPr>
             <a:r>
-              <a:rPr sz="1000" b="1" spc="160">
+              <a:rPr sz="1100" b="1" spc="160">
                 <a:solidFill>
                   <a:srgbClr val="C084FC"/>
                 </a:solidFill>
@@ -4579,8 +4579,8 @@
         </p:nvSpPr>
         <p:spPr>
           <a:xfrm>
-            <a:off x="3591991" y="3383280"/>
-            <a:ext cx="2192959" cy="1828800"/>
+            <a:off x="3637711" y="3246120"/>
+            <a:ext cx="2101519" cy="2651760"/>
           </a:xfrm>
           <a:prstGeom prst="rect">
             <a:avLst/>
@@ -4602,7 +4602,7 @@
               </a:spcAft>
             </a:pPr>
             <a:r>
-              <a:rPr sz="1200" b="0">
+              <a:rPr sz="1400" b="0">
                 <a:solidFill>
                   <a:srgbClr val="EDEDED"/>
                 </a:solidFill>
@@ -4621,8 +4621,8 @@
         </p:nvSpPr>
         <p:spPr>
           <a:xfrm>
-            <a:off x="6178143" y="2606040"/>
-            <a:ext cx="2650159" cy="2743200"/>
+            <a:off x="6178143" y="2377440"/>
+            <a:ext cx="2650159" cy="3657600"/>
           </a:xfrm>
           <a:prstGeom prst="rect">
             <a:avLst/>
@@ -4665,7 +4665,7 @@
         </p:nvSpPr>
         <p:spPr>
           <a:xfrm>
-            <a:off x="6178143" y="2606040"/>
+            <a:off x="6178143" y="2377440"/>
             <a:ext cx="2650159" cy="45720"/>
           </a:xfrm>
           <a:prstGeom prst="rect">
@@ -4709,8 +4709,8 @@
         </p:nvSpPr>
         <p:spPr>
           <a:xfrm>
-            <a:off x="6406743" y="2880360"/>
-            <a:ext cx="2192959" cy="365760"/>
+            <a:off x="6452463" y="2697480"/>
+            <a:ext cx="2101519" cy="365760"/>
           </a:xfrm>
           <a:prstGeom prst="rect">
             <a:avLst/>
@@ -4732,7 +4732,7 @@
               </a:spcAft>
             </a:pPr>
             <a:r>
-              <a:rPr sz="1000" b="1" spc="160">
+              <a:rPr sz="1100" b="1" spc="160">
                 <a:solidFill>
                   <a:srgbClr val="22C55E"/>
                 </a:solidFill>
@@ -4751,8 +4751,8 @@
         </p:nvSpPr>
         <p:spPr>
           <a:xfrm>
-            <a:off x="6406743" y="3383280"/>
-            <a:ext cx="2192959" cy="1828800"/>
+            <a:off x="6452463" y="3246120"/>
+            <a:ext cx="2101519" cy="2651760"/>
           </a:xfrm>
           <a:prstGeom prst="rect">
             <a:avLst/>
@@ -4774,7 +4774,7 @@
               </a:spcAft>
             </a:pPr>
             <a:r>
-              <a:rPr sz="1200" b="0">
+              <a:rPr sz="1400" b="0">
                 <a:solidFill>
                   <a:srgbClr val="EDEDED"/>
                 </a:solidFill>
@@ -4793,8 +4793,8 @@
         </p:nvSpPr>
         <p:spPr>
           <a:xfrm>
-            <a:off x="8992895" y="2606040"/>
-            <a:ext cx="2650159" cy="2743200"/>
+            <a:off x="8992895" y="2377440"/>
+            <a:ext cx="2650159" cy="3657600"/>
           </a:xfrm>
           <a:prstGeom prst="rect">
             <a:avLst/>
@@ -4837,7 +4837,7 @@
         </p:nvSpPr>
         <p:spPr>
           <a:xfrm>
-            <a:off x="8992895" y="2606040"/>
+            <a:off x="8992895" y="2377440"/>
             <a:ext cx="2650159" cy="45720"/>
           </a:xfrm>
           <a:prstGeom prst="rect">
@@ -4881,8 +4881,8 @@
         </p:nvSpPr>
         <p:spPr>
           <a:xfrm>
-            <a:off x="9221495" y="2880360"/>
-            <a:ext cx="2192959" cy="365760"/>
+            <a:off x="9267215" y="2697480"/>
+            <a:ext cx="2101519" cy="365760"/>
           </a:xfrm>
           <a:prstGeom prst="rect">
             <a:avLst/>
@@ -4904,7 +4904,7 @@
               </a:spcAft>
             </a:pPr>
             <a:r>
-              <a:rPr sz="1000" b="1" spc="160">
+              <a:rPr sz="1100" b="1" spc="160">
                 <a:solidFill>
                   <a:srgbClr val="FB923C"/>
                 </a:solidFill>
@@ -4923,8 +4923,8 @@
         </p:nvSpPr>
         <p:spPr>
           <a:xfrm>
-            <a:off x="9221495" y="3383280"/>
-            <a:ext cx="2192959" cy="1828800"/>
+            <a:off x="9267215" y="3246120"/>
+            <a:ext cx="2101519" cy="2651760"/>
           </a:xfrm>
           <a:prstGeom prst="rect">
             <a:avLst/>
@@ -4946,55 +4946,13 @@
               </a:spcAft>
             </a:pPr>
             <a:r>
-              <a:rPr sz="1200" b="0">
+              <a:rPr sz="1400" b="0">
                 <a:solidFill>
                   <a:srgbClr val="EDEDED"/>
                 </a:solidFill>
                 <a:latin typeface="Inter"/>
               </a:rPr>
               <a:t>Know what runs on your laptop versus what needs an API key.</a:t>
-            </a:r>
-          </a:p>
-        </p:txBody>
-      </p:sp>
-      <p:sp>
-        <p:nvSpPr>
-          <p:cNvPr id="26" name="TextBox 25"/>
-          <p:cNvSpPr txBox="1"/>
-          <p:nvPr/>
-        </p:nvSpPr>
-        <p:spPr>
-          <a:xfrm>
-            <a:off x="548640" y="5715000"/>
-            <a:ext cx="10972800" cy="365760"/>
-          </a:xfrm>
-          <a:prstGeom prst="rect">
-            <a:avLst/>
-          </a:prstGeom>
-          <a:noFill/>
-        </p:spPr>
-        <p:txBody>
-          <a:bodyPr wrap="square" lIns="0" rIns="0" tIns="0" bIns="0" anchor="t">
-            <a:spAutoFit/>
-          </a:bodyPr>
-          <a:lstStyle/>
-          <a:p>
-            <a:pPr algn="l">
-              <a:spcBef>
-                <a:spcPts val="0"/>
-              </a:spcBef>
-              <a:spcAft>
-                <a:spcPts val="0"/>
-              </a:spcAft>
-            </a:pPr>
-            <a:r>
-              <a:rPr sz="1200" b="0">
-                <a:solidFill>
-                  <a:srgbClr val="666666"/>
-                </a:solidFill>
-                <a:latin typeface="Inter"/>
-              </a:rPr>
-              <a:t>AI Frontier puts every comparison in one place, so the answer is a glance, not a spreadsheet.</a:t>
             </a:r>
           </a:p>
         </p:txBody>
@@ -6829,8 +6787,8 @@
         </p:nvSpPr>
         <p:spPr>
           <a:xfrm>
-            <a:off x="548640" y="2331720"/>
-            <a:ext cx="2650159" cy="2194560"/>
+            <a:off x="548640" y="2240280"/>
+            <a:ext cx="2650159" cy="2834640"/>
           </a:xfrm>
           <a:prstGeom prst="rect">
             <a:avLst/>
@@ -6873,7 +6831,7 @@
         </p:nvSpPr>
         <p:spPr>
           <a:xfrm>
-            <a:off x="548640" y="2331720"/>
+            <a:off x="548640" y="2240280"/>
             <a:ext cx="2650159" cy="45720"/>
           </a:xfrm>
           <a:prstGeom prst="rect">
@@ -6917,8 +6875,8 @@
         </p:nvSpPr>
         <p:spPr>
           <a:xfrm>
-            <a:off x="777240" y="2606040"/>
-            <a:ext cx="2192959" cy="274320"/>
+            <a:off x="822960" y="2560320"/>
+            <a:ext cx="2101519" cy="274320"/>
           </a:xfrm>
           <a:prstGeom prst="rect">
             <a:avLst/>
@@ -6940,7 +6898,7 @@
               </a:spcAft>
             </a:pPr>
             <a:r>
-              <a:rPr sz="1000" b="1" spc="160">
+              <a:rPr sz="1100" b="1" spc="160">
                 <a:solidFill>
                   <a:srgbClr val="00D4FF"/>
                 </a:solidFill>
@@ -6959,8 +6917,8 @@
         </p:nvSpPr>
         <p:spPr>
           <a:xfrm>
-            <a:off x="777240" y="3108960"/>
-            <a:ext cx="2192959" cy="914400"/>
+            <a:off x="822960" y="3017520"/>
+            <a:ext cx="2101519" cy="1188720"/>
           </a:xfrm>
           <a:prstGeom prst="rect">
             <a:avLst/>
@@ -6982,7 +6940,7 @@
               </a:spcAft>
             </a:pPr>
             <a:r>
-              <a:rPr sz="1300" b="0">
+              <a:rPr sz="1500" b="0">
                 <a:solidFill>
                   <a:srgbClr val="EDEDED"/>
                 </a:solidFill>
@@ -7001,8 +6959,8 @@
         </p:nvSpPr>
         <p:spPr>
           <a:xfrm>
-            <a:off x="777240" y="4023360"/>
-            <a:ext cx="2192959" cy="274320"/>
+            <a:off x="822960" y="4251960"/>
+            <a:ext cx="2101519" cy="228600"/>
           </a:xfrm>
           <a:prstGeom prst="rect">
             <a:avLst/>
@@ -7043,8 +7001,8 @@
         </p:nvSpPr>
         <p:spPr>
           <a:xfrm>
-            <a:off x="777240" y="4206239"/>
-            <a:ext cx="2192959" cy="274320"/>
+            <a:off x="822960" y="4480560"/>
+            <a:ext cx="2101519" cy="365760"/>
           </a:xfrm>
           <a:prstGeom prst="rect">
             <a:avLst/>
@@ -7066,7 +7024,7 @@
               </a:spcAft>
             </a:pPr>
             <a:r>
-              <a:rPr sz="1000" b="0">
+              <a:rPr sz="1100" b="0">
                 <a:solidFill>
                   <a:srgbClr val="888888"/>
                 </a:solidFill>
@@ -7085,8 +7043,8 @@
         </p:nvSpPr>
         <p:spPr>
           <a:xfrm>
-            <a:off x="3363391" y="2331720"/>
-            <a:ext cx="2650159" cy="2194560"/>
+            <a:off x="3363391" y="2240280"/>
+            <a:ext cx="2650159" cy="2834640"/>
           </a:xfrm>
           <a:prstGeom prst="rect">
             <a:avLst/>
@@ -7129,7 +7087,7 @@
         </p:nvSpPr>
         <p:spPr>
           <a:xfrm>
-            <a:off x="3363391" y="2331720"/>
+            <a:off x="3363391" y="2240280"/>
             <a:ext cx="2650159" cy="45720"/>
           </a:xfrm>
           <a:prstGeom prst="rect">
@@ -7173,8 +7131,8 @@
         </p:nvSpPr>
         <p:spPr>
           <a:xfrm>
-            <a:off x="3591991" y="2606040"/>
-            <a:ext cx="2192959" cy="274320"/>
+            <a:off x="3637711" y="2560320"/>
+            <a:ext cx="2101519" cy="274320"/>
           </a:xfrm>
           <a:prstGeom prst="rect">
             <a:avLst/>
@@ -7196,7 +7154,7 @@
               </a:spcAft>
             </a:pPr>
             <a:r>
-              <a:rPr sz="1000" b="1" spc="160">
+              <a:rPr sz="1100" b="1" spc="160">
                 <a:solidFill>
                   <a:srgbClr val="C084FC"/>
                 </a:solidFill>
@@ -7215,8 +7173,8 @@
         </p:nvSpPr>
         <p:spPr>
           <a:xfrm>
-            <a:off x="3591991" y="3108960"/>
-            <a:ext cx="2192959" cy="914400"/>
+            <a:off x="3637711" y="3017520"/>
+            <a:ext cx="2101519" cy="1188720"/>
           </a:xfrm>
           <a:prstGeom prst="rect">
             <a:avLst/>
@@ -7238,7 +7196,7 @@
               </a:spcAft>
             </a:pPr>
             <a:r>
-              <a:rPr sz="1300" b="0">
+              <a:rPr sz="1500" b="0">
                 <a:solidFill>
                   <a:srgbClr val="EDEDED"/>
                 </a:solidFill>
@@ -7257,8 +7215,8 @@
         </p:nvSpPr>
         <p:spPr>
           <a:xfrm>
-            <a:off x="3591991" y="4023360"/>
-            <a:ext cx="2192959" cy="274320"/>
+            <a:off x="3637711" y="4251960"/>
+            <a:ext cx="2101519" cy="228600"/>
           </a:xfrm>
           <a:prstGeom prst="rect">
             <a:avLst/>
@@ -7299,8 +7257,8 @@
         </p:nvSpPr>
         <p:spPr>
           <a:xfrm>
-            <a:off x="3591991" y="4206239"/>
-            <a:ext cx="2192959" cy="274320"/>
+            <a:off x="3637711" y="4480560"/>
+            <a:ext cx="2101519" cy="365760"/>
           </a:xfrm>
           <a:prstGeom prst="rect">
             <a:avLst/>
@@ -7322,7 +7280,7 @@
               </a:spcAft>
             </a:pPr>
             <a:r>
-              <a:rPr sz="1000" b="0">
+              <a:rPr sz="1100" b="0">
                 <a:solidFill>
                   <a:srgbClr val="888888"/>
                 </a:solidFill>
@@ -7341,8 +7299,8 @@
         </p:nvSpPr>
         <p:spPr>
           <a:xfrm>
-            <a:off x="6178143" y="2331720"/>
-            <a:ext cx="2650159" cy="2194560"/>
+            <a:off x="6178143" y="2240280"/>
+            <a:ext cx="2650159" cy="2834640"/>
           </a:xfrm>
           <a:prstGeom prst="rect">
             <a:avLst/>
@@ -7385,7 +7343,7 @@
         </p:nvSpPr>
         <p:spPr>
           <a:xfrm>
-            <a:off x="6178143" y="2331720"/>
+            <a:off x="6178143" y="2240280"/>
             <a:ext cx="2650159" cy="45720"/>
           </a:xfrm>
           <a:prstGeom prst="rect">
@@ -7429,8 +7387,8 @@
         </p:nvSpPr>
         <p:spPr>
           <a:xfrm>
-            <a:off x="6406743" y="2606040"/>
-            <a:ext cx="2192959" cy="274320"/>
+            <a:off x="6452463" y="2560320"/>
+            <a:ext cx="2101519" cy="274320"/>
           </a:xfrm>
           <a:prstGeom prst="rect">
             <a:avLst/>
@@ -7452,7 +7410,7 @@
               </a:spcAft>
             </a:pPr>
             <a:r>
-              <a:rPr sz="1000" b="1" spc="160">
+              <a:rPr sz="1100" b="1" spc="160">
                 <a:solidFill>
                   <a:srgbClr val="22C55E"/>
                 </a:solidFill>
@@ -7471,8 +7429,8 @@
         </p:nvSpPr>
         <p:spPr>
           <a:xfrm>
-            <a:off x="6406743" y="3108960"/>
-            <a:ext cx="2192959" cy="914400"/>
+            <a:off x="6452463" y="3017520"/>
+            <a:ext cx="2101519" cy="1188720"/>
           </a:xfrm>
           <a:prstGeom prst="rect">
             <a:avLst/>
@@ -7494,7 +7452,7 @@
               </a:spcAft>
             </a:pPr>
             <a:r>
-              <a:rPr sz="1300" b="0">
+              <a:rPr sz="1500" b="0">
                 <a:solidFill>
                   <a:srgbClr val="EDEDED"/>
                 </a:solidFill>
@@ -7513,8 +7471,8 @@
         </p:nvSpPr>
         <p:spPr>
           <a:xfrm>
-            <a:off x="6406743" y="4023360"/>
-            <a:ext cx="2192959" cy="274320"/>
+            <a:off x="6452463" y="4251960"/>
+            <a:ext cx="2101519" cy="228600"/>
           </a:xfrm>
           <a:prstGeom prst="rect">
             <a:avLst/>
@@ -7555,8 +7513,8 @@
         </p:nvSpPr>
         <p:spPr>
           <a:xfrm>
-            <a:off x="6406743" y="4206239"/>
-            <a:ext cx="2192959" cy="274320"/>
+            <a:off x="6452463" y="4480560"/>
+            <a:ext cx="2101519" cy="365760"/>
           </a:xfrm>
           <a:prstGeom prst="rect">
             <a:avLst/>
@@ -7578,7 +7536,7 @@
               </a:spcAft>
             </a:pPr>
             <a:r>
-              <a:rPr sz="1000" b="0">
+              <a:rPr sz="1100" b="0">
                 <a:solidFill>
                   <a:srgbClr val="888888"/>
                 </a:solidFill>
@@ -7597,8 +7555,8 @@
         </p:nvSpPr>
         <p:spPr>
           <a:xfrm>
-            <a:off x="8992895" y="2331720"/>
-            <a:ext cx="2650159" cy="2194560"/>
+            <a:off x="8992895" y="2240280"/>
+            <a:ext cx="2650159" cy="2834640"/>
           </a:xfrm>
           <a:prstGeom prst="rect">
             <a:avLst/>
@@ -7641,7 +7599,7 @@
         </p:nvSpPr>
         <p:spPr>
           <a:xfrm>
-            <a:off x="8992895" y="2331720"/>
+            <a:off x="8992895" y="2240280"/>
             <a:ext cx="2650159" cy="45720"/>
           </a:xfrm>
           <a:prstGeom prst="rect">
@@ -7685,8 +7643,8 @@
         </p:nvSpPr>
         <p:spPr>
           <a:xfrm>
-            <a:off x="9221495" y="2606040"/>
-            <a:ext cx="2192959" cy="274320"/>
+            <a:off x="9267215" y="2560320"/>
+            <a:ext cx="2101519" cy="274320"/>
           </a:xfrm>
           <a:prstGeom prst="rect">
             <a:avLst/>
@@ -7708,7 +7666,7 @@
               </a:spcAft>
             </a:pPr>
             <a:r>
-              <a:rPr sz="1000" b="1" spc="160">
+              <a:rPr sz="1100" b="1" spc="160">
                 <a:solidFill>
                   <a:srgbClr val="FB923C"/>
                 </a:solidFill>
@@ -7727,8 +7685,8 @@
         </p:nvSpPr>
         <p:spPr>
           <a:xfrm>
-            <a:off x="9221495" y="3108960"/>
-            <a:ext cx="2192959" cy="914400"/>
+            <a:off x="9267215" y="3017520"/>
+            <a:ext cx="2101519" cy="1188720"/>
           </a:xfrm>
           <a:prstGeom prst="rect">
             <a:avLst/>
@@ -7750,7 +7708,7 @@
               </a:spcAft>
             </a:pPr>
             <a:r>
-              <a:rPr sz="1300" b="0">
+              <a:rPr sz="1500" b="0">
                 <a:solidFill>
                   <a:srgbClr val="EDEDED"/>
                 </a:solidFill>
@@ -7769,8 +7727,8 @@
         </p:nvSpPr>
         <p:spPr>
           <a:xfrm>
-            <a:off x="9221495" y="4023360"/>
-            <a:ext cx="2192959" cy="274320"/>
+            <a:off x="9267215" y="4251960"/>
+            <a:ext cx="2101519" cy="228600"/>
           </a:xfrm>
           <a:prstGeom prst="rect">
             <a:avLst/>
@@ -7811,8 +7769,8 @@
         </p:nvSpPr>
         <p:spPr>
           <a:xfrm>
-            <a:off x="9221495" y="4206239"/>
-            <a:ext cx="2192959" cy="274320"/>
+            <a:off x="9267215" y="4480560"/>
+            <a:ext cx="2101519" cy="365760"/>
           </a:xfrm>
           <a:prstGeom prst="rect">
             <a:avLst/>
@@ -7834,7 +7792,7 @@
               </a:spcAft>
             </a:pPr>
             <a:r>
-              <a:rPr sz="1000" b="0">
+              <a:rPr sz="1100" b="0">
                 <a:solidFill>
                   <a:srgbClr val="888888"/>
                 </a:solidFill>
@@ -7853,8 +7811,8 @@
         </p:nvSpPr>
         <p:spPr>
           <a:xfrm>
-            <a:off x="548640" y="4846320"/>
-            <a:ext cx="11094415" cy="1280160"/>
+            <a:off x="548640" y="5349240"/>
+            <a:ext cx="11094415" cy="822960"/>
           </a:xfrm>
           <a:prstGeom prst="rect">
             <a:avLst/>
@@ -7897,7 +7855,7 @@
         </p:nvSpPr>
         <p:spPr>
           <a:xfrm>
-            <a:off x="777240" y="5074920"/>
+            <a:off x="777240" y="5532120"/>
             <a:ext cx="10972800" cy="274320"/>
           </a:xfrm>
           <a:prstGeom prst="rect">
@@ -7939,8 +7897,8 @@
         </p:nvSpPr>
         <p:spPr>
           <a:xfrm>
-            <a:off x="777240" y="5349240"/>
-            <a:ext cx="10972800" cy="365760"/>
+            <a:off x="777240" y="5788152"/>
+            <a:ext cx="10972800" cy="320040"/>
           </a:xfrm>
           <a:prstGeom prst="rect">
             <a:avLst/>
@@ -7964,53 +7922,11 @@
             <a:r>
               <a:rPr sz="1200" b="0">
                 <a:solidFill>
-                  <a:srgbClr val="EDEDED"/>
-                </a:solidFill>
-                <a:latin typeface="Inter"/>
-              </a:rPr>
-              <a:t>A model that wins on knowledge but flunks coding looks great on a single chart and misleading everywhere else.</a:t>
-            </a:r>
-          </a:p>
-        </p:txBody>
-      </p:sp>
-      <p:sp>
-        <p:nvSpPr>
-          <p:cNvPr id="37" name="TextBox 36"/>
-          <p:cNvSpPr txBox="1"/>
-          <p:nvPr/>
-        </p:nvSpPr>
-        <p:spPr>
-          <a:xfrm>
-            <a:off x="777240" y="5715000"/>
-            <a:ext cx="10972800" cy="365760"/>
-          </a:xfrm>
-          <a:prstGeom prst="rect">
-            <a:avLst/>
-          </a:prstGeom>
-          <a:noFill/>
-        </p:spPr>
-        <p:txBody>
-          <a:bodyPr wrap="square" lIns="0" rIns="0" tIns="0" bIns="0" anchor="t">
-            <a:spAutoFit/>
-          </a:bodyPr>
-          <a:lstStyle/>
-          <a:p>
-            <a:pPr algn="l">
-              <a:spcBef>
-                <a:spcPts val="0"/>
-              </a:spcBef>
-              <a:spcAft>
-                <a:spcPts val="0"/>
-              </a:spcAft>
-            </a:pPr>
-            <a:r>
-              <a:rPr sz="1200" b="0">
-                <a:solidFill>
                   <a:srgbClr val="888888"/>
                 </a:solidFill>
                 <a:latin typeface="Inter"/>
               </a:rPr>
-              <a:t>Averaging several tests rewards well-rounded models and lets one number sit on every chart in the dashboard.</a:t>
+              <a:t>One number rewards well-rounded models and lets you compare cloud and local models on the same scale.</a:t>
             </a:r>
           </a:p>
         </p:txBody>
@@ -8386,8 +8302,8 @@
         </p:nvSpPr>
         <p:spPr>
           <a:xfrm>
-            <a:off x="548640" y="2331720"/>
-            <a:ext cx="2101839" cy="3291840"/>
+            <a:off x="548640" y="2148840"/>
+            <a:ext cx="2101839" cy="3749039"/>
           </a:xfrm>
           <a:prstGeom prst="rect">
             <a:avLst/>
@@ -8430,7 +8346,7 @@
         </p:nvSpPr>
         <p:spPr>
           <a:xfrm>
-            <a:off x="548640" y="2331720"/>
+            <a:off x="548640" y="2148840"/>
             <a:ext cx="2101839" cy="45720"/>
           </a:xfrm>
           <a:prstGeom prst="rect">
@@ -8474,7 +8390,7 @@
         </p:nvSpPr>
         <p:spPr>
           <a:xfrm>
-            <a:off x="777240" y="2651760"/>
+            <a:off x="777240" y="2496312"/>
             <a:ext cx="1644639" cy="548640"/>
           </a:xfrm>
           <a:prstGeom prst="rect">
@@ -8497,7 +8413,7 @@
               </a:spcAft>
             </a:pPr>
             <a:r>
-              <a:rPr sz="2000" b="1">
+              <a:rPr sz="2200" b="1">
                 <a:solidFill>
                   <a:srgbClr val="EDEDED"/>
                 </a:solidFill>
@@ -8516,7 +8432,7 @@
         </p:nvSpPr>
         <p:spPr>
           <a:xfrm>
-            <a:off x="777240" y="3200400"/>
+            <a:off x="777240" y="3108960"/>
             <a:ext cx="1644639" cy="274320"/>
           </a:xfrm>
           <a:prstGeom prst="rect">
@@ -8539,7 +8455,7 @@
               </a:spcAft>
             </a:pPr>
             <a:r>
-              <a:rPr sz="800" b="1" spc="140">
+              <a:rPr sz="900" b="1" spc="140">
                 <a:solidFill>
                   <a:srgbClr val="00D4FF"/>
                 </a:solidFill>
@@ -8558,8 +8474,8 @@
         </p:nvSpPr>
         <p:spPr>
           <a:xfrm>
-            <a:off x="777240" y="3566160"/>
-            <a:ext cx="1644639" cy="1920240"/>
+            <a:off x="777240" y="3520440"/>
+            <a:ext cx="1644639" cy="2286000"/>
           </a:xfrm>
           <a:prstGeom prst="rect">
             <a:avLst/>
@@ -8581,7 +8497,7 @@
               </a:spcAft>
             </a:pPr>
             <a:r>
-              <a:rPr sz="1100" b="0">
+              <a:rPr sz="1200" b="0">
                 <a:solidFill>
                   <a:srgbClr val="888888"/>
                 </a:solidFill>
@@ -8600,8 +8516,8 @@
         </p:nvSpPr>
         <p:spPr>
           <a:xfrm>
-            <a:off x="2796783" y="2331720"/>
-            <a:ext cx="2101839" cy="3291840"/>
+            <a:off x="2796783" y="2148840"/>
+            <a:ext cx="2101839" cy="3749039"/>
           </a:xfrm>
           <a:prstGeom prst="rect">
             <a:avLst/>
@@ -8644,7 +8560,7 @@
         </p:nvSpPr>
         <p:spPr>
           <a:xfrm>
-            <a:off x="2796783" y="2331720"/>
+            <a:off x="2796783" y="2148840"/>
             <a:ext cx="2101839" cy="45720"/>
           </a:xfrm>
           <a:prstGeom prst="rect">
@@ -8688,7 +8604,7 @@
         </p:nvSpPr>
         <p:spPr>
           <a:xfrm>
-            <a:off x="3025383" y="2651760"/>
+            <a:off x="3025383" y="2496312"/>
             <a:ext cx="1644639" cy="548640"/>
           </a:xfrm>
           <a:prstGeom prst="rect">
@@ -8711,7 +8627,7 @@
               </a:spcAft>
             </a:pPr>
             <a:r>
-              <a:rPr sz="2000" b="1">
+              <a:rPr sz="2200" b="1">
                 <a:solidFill>
                   <a:srgbClr val="EDEDED"/>
                 </a:solidFill>
@@ -8730,7 +8646,7 @@
         </p:nvSpPr>
         <p:spPr>
           <a:xfrm>
-            <a:off x="3025383" y="3200400"/>
+            <a:off x="3025383" y="3108960"/>
             <a:ext cx="1644639" cy="274320"/>
           </a:xfrm>
           <a:prstGeom prst="rect">
@@ -8753,7 +8669,7 @@
               </a:spcAft>
             </a:pPr>
             <a:r>
-              <a:rPr sz="800" b="1" spc="140">
+              <a:rPr sz="900" b="1" spc="140">
                 <a:solidFill>
                   <a:srgbClr val="C084FC"/>
                 </a:solidFill>
@@ -8772,8 +8688,8 @@
         </p:nvSpPr>
         <p:spPr>
           <a:xfrm>
-            <a:off x="3025383" y="3566160"/>
-            <a:ext cx="1644639" cy="1920240"/>
+            <a:off x="3025383" y="3520440"/>
+            <a:ext cx="1644639" cy="2286000"/>
           </a:xfrm>
           <a:prstGeom prst="rect">
             <a:avLst/>
@@ -8795,7 +8711,7 @@
               </a:spcAft>
             </a:pPr>
             <a:r>
-              <a:rPr sz="1100" b="0">
+              <a:rPr sz="1200" b="0">
                 <a:solidFill>
                   <a:srgbClr val="888888"/>
                 </a:solidFill>
@@ -8814,8 +8730,8 @@
         </p:nvSpPr>
         <p:spPr>
           <a:xfrm>
-            <a:off x="5044927" y="2331720"/>
-            <a:ext cx="2101839" cy="3291840"/>
+            <a:off x="5044927" y="2148840"/>
+            <a:ext cx="2101839" cy="3749039"/>
           </a:xfrm>
           <a:prstGeom prst="rect">
             <a:avLst/>
@@ -8858,7 +8774,7 @@
         </p:nvSpPr>
         <p:spPr>
           <a:xfrm>
-            <a:off x="5044927" y="2331720"/>
+            <a:off x="5044927" y="2148840"/>
             <a:ext cx="2101839" cy="45720"/>
           </a:xfrm>
           <a:prstGeom prst="rect">
@@ -8902,7 +8818,7 @@
         </p:nvSpPr>
         <p:spPr>
           <a:xfrm>
-            <a:off x="5273527" y="2651760"/>
+            <a:off x="5273527" y="2496312"/>
             <a:ext cx="1644639" cy="548640"/>
           </a:xfrm>
           <a:prstGeom prst="rect">
@@ -8925,7 +8841,7 @@
               </a:spcAft>
             </a:pPr>
             <a:r>
-              <a:rPr sz="2000" b="1">
+              <a:rPr sz="2200" b="1">
                 <a:solidFill>
                   <a:srgbClr val="EDEDED"/>
                 </a:solidFill>
@@ -8944,7 +8860,7 @@
         </p:nvSpPr>
         <p:spPr>
           <a:xfrm>
-            <a:off x="5273527" y="3200400"/>
+            <a:off x="5273527" y="3108960"/>
             <a:ext cx="1644639" cy="274320"/>
           </a:xfrm>
           <a:prstGeom prst="rect">
@@ -8967,7 +8883,7 @@
               </a:spcAft>
             </a:pPr>
             <a:r>
-              <a:rPr sz="800" b="1" spc="140">
+              <a:rPr sz="900" b="1" spc="140">
                 <a:solidFill>
                   <a:srgbClr val="22C55E"/>
                 </a:solidFill>
@@ -8986,8 +8902,8 @@
         </p:nvSpPr>
         <p:spPr>
           <a:xfrm>
-            <a:off x="5273527" y="3566160"/>
-            <a:ext cx="1644639" cy="1920240"/>
+            <a:off x="5273527" y="3520440"/>
+            <a:ext cx="1644639" cy="2286000"/>
           </a:xfrm>
           <a:prstGeom prst="rect">
             <a:avLst/>
@@ -9009,7 +8925,7 @@
               </a:spcAft>
             </a:pPr>
             <a:r>
-              <a:rPr sz="1100" b="0">
+              <a:rPr sz="1200" b="0">
                 <a:solidFill>
                   <a:srgbClr val="888888"/>
                 </a:solidFill>
@@ -9028,8 +8944,8 @@
         </p:nvSpPr>
         <p:spPr>
           <a:xfrm>
-            <a:off x="7293071" y="2331720"/>
-            <a:ext cx="2101839" cy="3291840"/>
+            <a:off x="7293071" y="2148840"/>
+            <a:ext cx="2101839" cy="3749039"/>
           </a:xfrm>
           <a:prstGeom prst="rect">
             <a:avLst/>
@@ -9072,7 +8988,7 @@
         </p:nvSpPr>
         <p:spPr>
           <a:xfrm>
-            <a:off x="7293071" y="2331720"/>
+            <a:off x="7293071" y="2148840"/>
             <a:ext cx="2101839" cy="45720"/>
           </a:xfrm>
           <a:prstGeom prst="rect">
@@ -9116,7 +9032,7 @@
         </p:nvSpPr>
         <p:spPr>
           <a:xfrm>
-            <a:off x="7521671" y="2651760"/>
+            <a:off x="7521671" y="2496312"/>
             <a:ext cx="1644639" cy="548640"/>
           </a:xfrm>
           <a:prstGeom prst="rect">
@@ -9139,7 +9055,7 @@
               </a:spcAft>
             </a:pPr>
             <a:r>
-              <a:rPr sz="2000" b="1">
+              <a:rPr sz="2200" b="1">
                 <a:solidFill>
                   <a:srgbClr val="EDEDED"/>
                 </a:solidFill>
@@ -9158,7 +9074,7 @@
         </p:nvSpPr>
         <p:spPr>
           <a:xfrm>
-            <a:off x="7521671" y="3200400"/>
+            <a:off x="7521671" y="3108960"/>
             <a:ext cx="1644639" cy="274320"/>
           </a:xfrm>
           <a:prstGeom prst="rect">
@@ -9181,7 +9097,7 @@
               </a:spcAft>
             </a:pPr>
             <a:r>
-              <a:rPr sz="800" b="1" spc="140">
+              <a:rPr sz="900" b="1" spc="140">
                 <a:solidFill>
                   <a:srgbClr val="FB923C"/>
                 </a:solidFill>
@@ -9200,8 +9116,8 @@
         </p:nvSpPr>
         <p:spPr>
           <a:xfrm>
-            <a:off x="7521671" y="3566160"/>
-            <a:ext cx="1644639" cy="1920240"/>
+            <a:off x="7521671" y="3520440"/>
+            <a:ext cx="1644639" cy="2286000"/>
           </a:xfrm>
           <a:prstGeom prst="rect">
             <a:avLst/>
@@ -9223,7 +9139,7 @@
               </a:spcAft>
             </a:pPr>
             <a:r>
-              <a:rPr sz="1100" b="0">
+              <a:rPr sz="1200" b="0">
                 <a:solidFill>
                   <a:srgbClr val="888888"/>
                 </a:solidFill>
@@ -9242,8 +9158,8 @@
         </p:nvSpPr>
         <p:spPr>
           <a:xfrm>
-            <a:off x="9541215" y="2331720"/>
-            <a:ext cx="2101839" cy="3291840"/>
+            <a:off x="9541215" y="2148840"/>
+            <a:ext cx="2101839" cy="3749039"/>
           </a:xfrm>
           <a:prstGeom prst="rect">
             <a:avLst/>
@@ -9286,7 +9202,7 @@
         </p:nvSpPr>
         <p:spPr>
           <a:xfrm>
-            <a:off x="9541215" y="2331720"/>
+            <a:off x="9541215" y="2148840"/>
             <a:ext cx="2101839" cy="45720"/>
           </a:xfrm>
           <a:prstGeom prst="rect">
@@ -9330,7 +9246,7 @@
         </p:nvSpPr>
         <p:spPr>
           <a:xfrm>
-            <a:off x="9769815" y="2651760"/>
+            <a:off x="9769815" y="2496312"/>
             <a:ext cx="1644639" cy="548640"/>
           </a:xfrm>
           <a:prstGeom prst="rect">
@@ -9353,7 +9269,7 @@
               </a:spcAft>
             </a:pPr>
             <a:r>
-              <a:rPr sz="2000" b="1">
+              <a:rPr sz="2200" b="1">
                 <a:solidFill>
                   <a:srgbClr val="EDEDED"/>
                 </a:solidFill>
@@ -9372,7 +9288,7 @@
         </p:nvSpPr>
         <p:spPr>
           <a:xfrm>
-            <a:off x="9769815" y="3200400"/>
+            <a:off x="9769815" y="3108960"/>
             <a:ext cx="1644639" cy="274320"/>
           </a:xfrm>
           <a:prstGeom prst="rect">
@@ -9395,7 +9311,7 @@
               </a:spcAft>
             </a:pPr>
             <a:r>
-              <a:rPr sz="800" b="1" spc="140">
+              <a:rPr sz="900" b="1" spc="140">
                 <a:solidFill>
                   <a:srgbClr val="7C3AED"/>
                 </a:solidFill>
@@ -9414,8 +9330,8 @@
         </p:nvSpPr>
         <p:spPr>
           <a:xfrm>
-            <a:off x="9769815" y="3566160"/>
-            <a:ext cx="1644639" cy="1920240"/>
+            <a:off x="9769815" y="3520440"/>
+            <a:ext cx="1644639" cy="2286000"/>
           </a:xfrm>
           <a:prstGeom prst="rect">
             <a:avLst/>
@@ -9437,7 +9353,7 @@
               </a:spcAft>
             </a:pPr>
             <a:r>
-              <a:rPr sz="1100" b="0">
+              <a:rPr sz="1200" b="0">
                 <a:solidFill>
                   <a:srgbClr val="888888"/>
                 </a:solidFill>
@@ -9864,7 +9780,7 @@
         <p:spPr>
           <a:xfrm>
             <a:off x="914400" y="2560320"/>
-            <a:ext cx="73152" cy="365760"/>
+            <a:ext cx="73152" cy="411480"/>
           </a:xfrm>
           <a:prstGeom prst="rect">
             <a:avLst/>
@@ -9908,6 +9824,48 @@
         <p:spPr>
           <a:xfrm>
             <a:off x="1097280" y="2514600"/>
+            <a:ext cx="4846320" cy="320040"/>
+          </a:xfrm>
+          <a:prstGeom prst="rect">
+            <a:avLst/>
+          </a:prstGeom>
+          <a:noFill/>
+        </p:spPr>
+        <p:txBody>
+          <a:bodyPr wrap="square" lIns="0" rIns="0" tIns="0" bIns="0" anchor="t">
+            <a:spAutoFit/>
+          </a:bodyPr>
+          <a:lstStyle/>
+          <a:p>
+            <a:pPr algn="l">
+              <a:spcBef>
+                <a:spcPts val="0"/>
+              </a:spcBef>
+              <a:spcAft>
+                <a:spcPts val="0"/>
+              </a:spcAft>
+            </a:pPr>
+            <a:r>
+              <a:rPr sz="1500" b="1">
+                <a:solidFill>
+                  <a:srgbClr val="EDEDED"/>
+                </a:solidFill>
+                <a:latin typeface="Inter"/>
+              </a:rPr>
+              <a:t>Bubble scatter</a:t>
+            </a:r>
+          </a:p>
+        </p:txBody>
+      </p:sp>
+      <p:sp>
+        <p:nvSpPr>
+          <p:cNvPr id="13" name="TextBox 12"/>
+          <p:cNvSpPr txBox="1"/>
+          <p:nvPr/>
+        </p:nvSpPr>
+        <p:spPr>
+          <a:xfrm>
+            <a:off x="1097280" y="2788920"/>
             <a:ext cx="4846320" cy="274320"/>
           </a:xfrm>
           <a:prstGeom prst="rect">
@@ -9930,49 +9888,7 @@
               </a:spcAft>
             </a:pPr>
             <a:r>
-              <a:rPr sz="1300" b="1">
-                <a:solidFill>
-                  <a:srgbClr val="EDEDED"/>
-                </a:solidFill>
-                <a:latin typeface="Inter"/>
-              </a:rPr>
-              <a:t>Bubble scatter</a:t>
-            </a:r>
-          </a:p>
-        </p:txBody>
-      </p:sp>
-      <p:sp>
-        <p:nvSpPr>
-          <p:cNvPr id="13" name="TextBox 12"/>
-          <p:cNvSpPr txBox="1"/>
-          <p:nvPr/>
-        </p:nvSpPr>
-        <p:spPr>
-          <a:xfrm>
-            <a:off x="1097280" y="2743200"/>
-            <a:ext cx="4846320" cy="274320"/>
-          </a:xfrm>
-          <a:prstGeom prst="rect">
-            <a:avLst/>
-          </a:prstGeom>
-          <a:noFill/>
-        </p:spPr>
-        <p:txBody>
-          <a:bodyPr wrap="square" lIns="0" rIns="0" tIns="0" bIns="0" anchor="t">
-            <a:spAutoFit/>
-          </a:bodyPr>
-          <a:lstStyle/>
-          <a:p>
-            <a:pPr algn="l">
-              <a:spcBef>
-                <a:spcPts val="0"/>
-              </a:spcBef>
-              <a:spcAft>
-                <a:spcPts val="0"/>
-              </a:spcAft>
-            </a:pPr>
-            <a:r>
-              <a:rPr sz="1000" b="0">
+              <a:rPr sz="1200" b="0">
                 <a:solidFill>
                   <a:srgbClr val="666666"/>
                 </a:solidFill>
@@ -9992,7 +9908,7 @@
         <p:spPr>
           <a:xfrm>
             <a:off x="914400" y="3154680"/>
-            <a:ext cx="73152" cy="365760"/>
+            <a:ext cx="73152" cy="411480"/>
           </a:xfrm>
           <a:prstGeom prst="rect">
             <a:avLst/>
@@ -10036,6 +9952,48 @@
         <p:spPr>
           <a:xfrm>
             <a:off x="1097280" y="3108960"/>
+            <a:ext cx="4846320" cy="320040"/>
+          </a:xfrm>
+          <a:prstGeom prst="rect">
+            <a:avLst/>
+          </a:prstGeom>
+          <a:noFill/>
+        </p:spPr>
+        <p:txBody>
+          <a:bodyPr wrap="square" lIns="0" rIns="0" tIns="0" bIns="0" anchor="t">
+            <a:spAutoFit/>
+          </a:bodyPr>
+          <a:lstStyle/>
+          <a:p>
+            <a:pPr algn="l">
+              <a:spcBef>
+                <a:spcPts val="0"/>
+              </a:spcBef>
+              <a:spcAft>
+                <a:spcPts val="0"/>
+              </a:spcAft>
+            </a:pPr>
+            <a:r>
+              <a:rPr sz="1500" b="1">
+                <a:solidFill>
+                  <a:srgbClr val="EDEDED"/>
+                </a:solidFill>
+                <a:latin typeface="Inter"/>
+              </a:rPr>
+              <a:t>Pareto frontier</a:t>
+            </a:r>
+          </a:p>
+        </p:txBody>
+      </p:sp>
+      <p:sp>
+        <p:nvSpPr>
+          <p:cNvPr id="16" name="TextBox 15"/>
+          <p:cNvSpPr txBox="1"/>
+          <p:nvPr/>
+        </p:nvSpPr>
+        <p:spPr>
+          <a:xfrm>
+            <a:off x="1097280" y="3383280"/>
             <a:ext cx="4846320" cy="274320"/>
           </a:xfrm>
           <a:prstGeom prst="rect">
@@ -10058,49 +10016,7 @@
               </a:spcAft>
             </a:pPr>
             <a:r>
-              <a:rPr sz="1300" b="1">
-                <a:solidFill>
-                  <a:srgbClr val="EDEDED"/>
-                </a:solidFill>
-                <a:latin typeface="Inter"/>
-              </a:rPr>
-              <a:t>Pareto frontier</a:t>
-            </a:r>
-          </a:p>
-        </p:txBody>
-      </p:sp>
-      <p:sp>
-        <p:nvSpPr>
-          <p:cNvPr id="16" name="TextBox 15"/>
-          <p:cNvSpPr txBox="1"/>
-          <p:nvPr/>
-        </p:nvSpPr>
-        <p:spPr>
-          <a:xfrm>
-            <a:off x="1097280" y="3337560"/>
-            <a:ext cx="4846320" cy="274320"/>
-          </a:xfrm>
-          <a:prstGeom prst="rect">
-            <a:avLst/>
-          </a:prstGeom>
-          <a:noFill/>
-        </p:spPr>
-        <p:txBody>
-          <a:bodyPr wrap="square" lIns="0" rIns="0" tIns="0" bIns="0" anchor="t">
-            <a:spAutoFit/>
-          </a:bodyPr>
-          <a:lstStyle/>
-          <a:p>
-            <a:pPr algn="l">
-              <a:spcBef>
-                <a:spcPts val="0"/>
-              </a:spcBef>
-              <a:spcAft>
-                <a:spcPts val="0"/>
-              </a:spcAft>
-            </a:pPr>
-            <a:r>
-              <a:rPr sz="1000" b="0">
+              <a:rPr sz="1200" b="0">
                 <a:solidFill>
                   <a:srgbClr val="666666"/>
                 </a:solidFill>
@@ -10120,7 +10036,7 @@
         <p:spPr>
           <a:xfrm>
             <a:off x="914400" y="3749040"/>
-            <a:ext cx="73152" cy="365760"/>
+            <a:ext cx="73152" cy="411480"/>
           </a:xfrm>
           <a:prstGeom prst="rect">
             <a:avLst/>
@@ -10164,6 +10080,48 @@
         <p:spPr>
           <a:xfrm>
             <a:off x="1097280" y="3703320"/>
+            <a:ext cx="4846320" cy="320040"/>
+          </a:xfrm>
+          <a:prstGeom prst="rect">
+            <a:avLst/>
+          </a:prstGeom>
+          <a:noFill/>
+        </p:spPr>
+        <p:txBody>
+          <a:bodyPr wrap="square" lIns="0" rIns="0" tIns="0" bIns="0" anchor="t">
+            <a:spAutoFit/>
+          </a:bodyPr>
+          <a:lstStyle/>
+          <a:p>
+            <a:pPr algn="l">
+              <a:spcBef>
+                <a:spcPts val="0"/>
+              </a:spcBef>
+              <a:spcAft>
+                <a:spcPts val="0"/>
+              </a:spcAft>
+            </a:pPr>
+            <a:r>
+              <a:rPr sz="1500" b="1">
+                <a:solidFill>
+                  <a:srgbClr val="EDEDED"/>
+                </a:solidFill>
+                <a:latin typeface="Inter"/>
+              </a:rPr>
+              <a:t>Treemap</a:t>
+            </a:r>
+          </a:p>
+        </p:txBody>
+      </p:sp>
+      <p:sp>
+        <p:nvSpPr>
+          <p:cNvPr id="19" name="TextBox 18"/>
+          <p:cNvSpPr txBox="1"/>
+          <p:nvPr/>
+        </p:nvSpPr>
+        <p:spPr>
+          <a:xfrm>
+            <a:off x="1097280" y="3977640"/>
             <a:ext cx="4846320" cy="274320"/>
           </a:xfrm>
           <a:prstGeom prst="rect">
@@ -10186,49 +10144,7 @@
               </a:spcAft>
             </a:pPr>
             <a:r>
-              <a:rPr sz="1300" b="1">
-                <a:solidFill>
-                  <a:srgbClr val="EDEDED"/>
-                </a:solidFill>
-                <a:latin typeface="Inter"/>
-              </a:rPr>
-              <a:t>Treemap</a:t>
-            </a:r>
-          </a:p>
-        </p:txBody>
-      </p:sp>
-      <p:sp>
-        <p:nvSpPr>
-          <p:cNvPr id="19" name="TextBox 18"/>
-          <p:cNvSpPr txBox="1"/>
-          <p:nvPr/>
-        </p:nvSpPr>
-        <p:spPr>
-          <a:xfrm>
-            <a:off x="1097280" y="3931920"/>
-            <a:ext cx="4846320" cy="274320"/>
-          </a:xfrm>
-          <a:prstGeom prst="rect">
-            <a:avLst/>
-          </a:prstGeom>
-          <a:noFill/>
-        </p:spPr>
-        <p:txBody>
-          <a:bodyPr wrap="square" lIns="0" rIns="0" tIns="0" bIns="0" anchor="t">
-            <a:spAutoFit/>
-          </a:bodyPr>
-          <a:lstStyle/>
-          <a:p>
-            <a:pPr algn="l">
-              <a:spcBef>
-                <a:spcPts val="0"/>
-              </a:spcBef>
-              <a:spcAft>
-                <a:spcPts val="0"/>
-              </a:spcAft>
-            </a:pPr>
-            <a:r>
-              <a:rPr sz="1000" b="0">
+              <a:rPr sz="1200" b="0">
                 <a:solidFill>
                   <a:srgbClr val="666666"/>
                 </a:solidFill>
@@ -10248,7 +10164,7 @@
         <p:spPr>
           <a:xfrm>
             <a:off x="914400" y="4343400"/>
-            <a:ext cx="73152" cy="365760"/>
+            <a:ext cx="73152" cy="411480"/>
           </a:xfrm>
           <a:prstGeom prst="rect">
             <a:avLst/>
@@ -10292,6 +10208,48 @@
         <p:spPr>
           <a:xfrm>
             <a:off x="1097280" y="4297680"/>
+            <a:ext cx="4846320" cy="320040"/>
+          </a:xfrm>
+          <a:prstGeom prst="rect">
+            <a:avLst/>
+          </a:prstGeom>
+          <a:noFill/>
+        </p:spPr>
+        <p:txBody>
+          <a:bodyPr wrap="square" lIns="0" rIns="0" tIns="0" bIns="0" anchor="t">
+            <a:spAutoFit/>
+          </a:bodyPr>
+          <a:lstStyle/>
+          <a:p>
+            <a:pPr algn="l">
+              <a:spcBef>
+                <a:spcPts val="0"/>
+              </a:spcBef>
+              <a:spcAft>
+                <a:spcPts val="0"/>
+              </a:spcAft>
+            </a:pPr>
+            <a:r>
+              <a:rPr sz="1500" b="1">
+                <a:solidFill>
+                  <a:srgbClr val="EDEDED"/>
+                </a:solidFill>
+                <a:latin typeface="Inter"/>
+              </a:rPr>
+              <a:t>Horizontal bars</a:t>
+            </a:r>
+          </a:p>
+        </p:txBody>
+      </p:sp>
+      <p:sp>
+        <p:nvSpPr>
+          <p:cNvPr id="22" name="TextBox 21"/>
+          <p:cNvSpPr txBox="1"/>
+          <p:nvPr/>
+        </p:nvSpPr>
+        <p:spPr>
+          <a:xfrm>
+            <a:off x="1097280" y="4572000"/>
             <a:ext cx="4846320" cy="274320"/>
           </a:xfrm>
           <a:prstGeom prst="rect">
@@ -10314,49 +10272,7 @@
               </a:spcAft>
             </a:pPr>
             <a:r>
-              <a:rPr sz="1300" b="1">
-                <a:solidFill>
-                  <a:srgbClr val="EDEDED"/>
-                </a:solidFill>
-                <a:latin typeface="Inter"/>
-              </a:rPr>
-              <a:t>Horizontal bars</a:t>
-            </a:r>
-          </a:p>
-        </p:txBody>
-      </p:sp>
-      <p:sp>
-        <p:nvSpPr>
-          <p:cNvPr id="22" name="TextBox 21"/>
-          <p:cNvSpPr txBox="1"/>
-          <p:nvPr/>
-        </p:nvSpPr>
-        <p:spPr>
-          <a:xfrm>
-            <a:off x="1097280" y="4526280"/>
-            <a:ext cx="4846320" cy="274320"/>
-          </a:xfrm>
-          <a:prstGeom prst="rect">
-            <a:avLst/>
-          </a:prstGeom>
-          <a:noFill/>
-        </p:spPr>
-        <p:txBody>
-          <a:bodyPr wrap="square" lIns="0" rIns="0" tIns="0" bIns="0" anchor="t">
-            <a:spAutoFit/>
-          </a:bodyPr>
-          <a:lstStyle/>
-          <a:p>
-            <a:pPr algn="l">
-              <a:spcBef>
-                <a:spcPts val="0"/>
-              </a:spcBef>
-              <a:spcAft>
-                <a:spcPts val="0"/>
-              </a:spcAft>
-            </a:pPr>
-            <a:r>
-              <a:rPr sz="1000" b="0">
+              <a:rPr sz="1200" b="0">
                 <a:solidFill>
                   <a:srgbClr val="666666"/>
                 </a:solidFill>
@@ -10376,7 +10292,7 @@
         <p:spPr>
           <a:xfrm>
             <a:off x="914400" y="4937760"/>
-            <a:ext cx="73152" cy="365760"/>
+            <a:ext cx="73152" cy="411480"/>
           </a:xfrm>
           <a:prstGeom prst="rect">
             <a:avLst/>
@@ -10420,6 +10336,48 @@
         <p:spPr>
           <a:xfrm>
             <a:off x="1097280" y="4892040"/>
+            <a:ext cx="4846320" cy="320040"/>
+          </a:xfrm>
+          <a:prstGeom prst="rect">
+            <a:avLst/>
+          </a:prstGeom>
+          <a:noFill/>
+        </p:spPr>
+        <p:txBody>
+          <a:bodyPr wrap="square" lIns="0" rIns="0" tIns="0" bIns="0" anchor="t">
+            <a:spAutoFit/>
+          </a:bodyPr>
+          <a:lstStyle/>
+          <a:p>
+            <a:pPr algn="l">
+              <a:spcBef>
+                <a:spcPts val="0"/>
+              </a:spcBef>
+              <a:spcAft>
+                <a:spcPts val="0"/>
+              </a:spcAft>
+            </a:pPr>
+            <a:r>
+              <a:rPr sz="1500" b="1">
+                <a:solidFill>
+                  <a:srgbClr val="EDEDED"/>
+                </a:solidFill>
+                <a:latin typeface="Inter"/>
+              </a:rPr>
+              <a:t>Radar</a:t>
+            </a:r>
+          </a:p>
+        </p:txBody>
+      </p:sp>
+      <p:sp>
+        <p:nvSpPr>
+          <p:cNvPr id="25" name="TextBox 24"/>
+          <p:cNvSpPr txBox="1"/>
+          <p:nvPr/>
+        </p:nvSpPr>
+        <p:spPr>
+          <a:xfrm>
+            <a:off x="1097280" y="5166360"/>
             <a:ext cx="4846320" cy="274320"/>
           </a:xfrm>
           <a:prstGeom prst="rect">
@@ -10442,49 +10400,7 @@
               </a:spcAft>
             </a:pPr>
             <a:r>
-              <a:rPr sz="1300" b="1">
-                <a:solidFill>
-                  <a:srgbClr val="EDEDED"/>
-                </a:solidFill>
-                <a:latin typeface="Inter"/>
-              </a:rPr>
-              <a:t>Radar</a:t>
-            </a:r>
-          </a:p>
-        </p:txBody>
-      </p:sp>
-      <p:sp>
-        <p:nvSpPr>
-          <p:cNvPr id="25" name="TextBox 24"/>
-          <p:cNvSpPr txBox="1"/>
-          <p:nvPr/>
-        </p:nvSpPr>
-        <p:spPr>
-          <a:xfrm>
-            <a:off x="1097280" y="5120640"/>
-            <a:ext cx="4846320" cy="274320"/>
-          </a:xfrm>
-          <a:prstGeom prst="rect">
-            <a:avLst/>
-          </a:prstGeom>
-          <a:noFill/>
-        </p:spPr>
-        <p:txBody>
-          <a:bodyPr wrap="square" lIns="0" rIns="0" tIns="0" bIns="0" anchor="t">
-            <a:spAutoFit/>
-          </a:bodyPr>
-          <a:lstStyle/>
-          <a:p>
-            <a:pPr algn="l">
-              <a:spcBef>
-                <a:spcPts val="0"/>
-              </a:spcBef>
-              <a:spcAft>
-                <a:spcPts val="0"/>
-              </a:spcAft>
-            </a:pPr>
-            <a:r>
-              <a:rPr sz="1000" b="0">
+              <a:rPr sz="1200" b="0">
                 <a:solidFill>
                   <a:srgbClr val="666666"/>
                 </a:solidFill>
@@ -10504,7 +10420,7 @@
         <p:spPr>
           <a:xfrm>
             <a:off x="914400" y="5532120"/>
-            <a:ext cx="73152" cy="365760"/>
+            <a:ext cx="73152" cy="411480"/>
           </a:xfrm>
           <a:prstGeom prst="rect">
             <a:avLst/>
@@ -10548,6 +10464,48 @@
         <p:spPr>
           <a:xfrm>
             <a:off x="1097280" y="5486400"/>
+            <a:ext cx="4846320" cy="320040"/>
+          </a:xfrm>
+          <a:prstGeom prst="rect">
+            <a:avLst/>
+          </a:prstGeom>
+          <a:noFill/>
+        </p:spPr>
+        <p:txBody>
+          <a:bodyPr wrap="square" lIns="0" rIns="0" tIns="0" bIns="0" anchor="t">
+            <a:spAutoFit/>
+          </a:bodyPr>
+          <a:lstStyle/>
+          <a:p>
+            <a:pPr algn="l">
+              <a:spcBef>
+                <a:spcPts val="0"/>
+              </a:spcBef>
+              <a:spcAft>
+                <a:spcPts val="0"/>
+              </a:spcAft>
+            </a:pPr>
+            <a:r>
+              <a:rPr sz="1500" b="1">
+                <a:solidFill>
+                  <a:srgbClr val="EDEDED"/>
+                </a:solidFill>
+                <a:latin typeface="Inter"/>
+              </a:rPr>
+              <a:t>Bump chart</a:t>
+            </a:r>
+          </a:p>
+        </p:txBody>
+      </p:sp>
+      <p:sp>
+        <p:nvSpPr>
+          <p:cNvPr id="28" name="TextBox 27"/>
+          <p:cNvSpPr txBox="1"/>
+          <p:nvPr/>
+        </p:nvSpPr>
+        <p:spPr>
+          <a:xfrm>
+            <a:off x="1097280" y="5760720"/>
             <a:ext cx="4846320" cy="274320"/>
           </a:xfrm>
           <a:prstGeom prst="rect">
@@ -10570,49 +10528,7 @@
               </a:spcAft>
             </a:pPr>
             <a:r>
-              <a:rPr sz="1300" b="1">
-                <a:solidFill>
-                  <a:srgbClr val="EDEDED"/>
-                </a:solidFill>
-                <a:latin typeface="Inter"/>
-              </a:rPr>
-              <a:t>Bump chart</a:t>
-            </a:r>
-          </a:p>
-        </p:txBody>
-      </p:sp>
-      <p:sp>
-        <p:nvSpPr>
-          <p:cNvPr id="28" name="TextBox 27"/>
-          <p:cNvSpPr txBox="1"/>
-          <p:nvPr/>
-        </p:nvSpPr>
-        <p:spPr>
-          <a:xfrm>
-            <a:off x="1097280" y="5715000"/>
-            <a:ext cx="4846320" cy="274320"/>
-          </a:xfrm>
-          <a:prstGeom prst="rect">
-            <a:avLst/>
-          </a:prstGeom>
-          <a:noFill/>
-        </p:spPr>
-        <p:txBody>
-          <a:bodyPr wrap="square" lIns="0" rIns="0" tIns="0" bIns="0" anchor="t">
-            <a:spAutoFit/>
-          </a:bodyPr>
-          <a:lstStyle/>
-          <a:p>
-            <a:pPr algn="l">
-              <a:spcBef>
-                <a:spcPts val="0"/>
-              </a:spcBef>
-              <a:spcAft>
-                <a:spcPts val="0"/>
-              </a:spcAft>
-            </a:pPr>
-            <a:r>
-              <a:rPr sz="1000" b="0">
+              <a:rPr sz="1200" b="0">
                 <a:solidFill>
                   <a:srgbClr val="666666"/>
                 </a:solidFill>
@@ -10740,7 +10656,7 @@
               </a:spcAft>
             </a:pPr>
             <a:r>
-              <a:rPr sz="1100" b="1" spc="140">
+              <a:rPr sz="1200" b="1" spc="140">
                 <a:solidFill>
                   <a:srgbClr val="00D4FF"/>
                 </a:solidFill>
@@ -10782,7 +10698,7 @@
               </a:spcAft>
             </a:pPr>
             <a:r>
-              <a:rPr sz="1300" b="1">
+              <a:rPr sz="1500" b="1">
                 <a:solidFill>
                   <a:srgbClr val="EDEDED"/>
                 </a:solidFill>
@@ -10801,7 +10717,7 @@
         </p:nvSpPr>
         <p:spPr>
           <a:xfrm>
-            <a:off x="7269480" y="2761488"/>
+            <a:off x="7269480" y="2816352"/>
             <a:ext cx="4160520" cy="548640"/>
           </a:xfrm>
           <a:prstGeom prst="rect">
@@ -10824,7 +10740,7 @@
               </a:spcAft>
             </a:pPr>
             <a:r>
-              <a:rPr sz="1000" b="0">
+              <a:rPr sz="1200" b="0">
                 <a:solidFill>
                   <a:srgbClr val="888888"/>
                 </a:solidFill>
@@ -10843,7 +10759,7 @@
         </p:nvSpPr>
         <p:spPr>
           <a:xfrm>
-            <a:off x="6858000" y="3337560"/>
+            <a:off x="6858000" y="3383280"/>
             <a:ext cx="457200" cy="274320"/>
           </a:xfrm>
           <a:prstGeom prst="rect">
@@ -10866,7 +10782,7 @@
               </a:spcAft>
             </a:pPr>
             <a:r>
-              <a:rPr sz="1100" b="1" spc="140">
+              <a:rPr sz="1200" b="1" spc="140">
                 <a:solidFill>
                   <a:srgbClr val="00D4FF"/>
                 </a:solidFill>
@@ -10885,7 +10801,7 @@
         </p:nvSpPr>
         <p:spPr>
           <a:xfrm>
-            <a:off x="7269480" y="3337560"/>
+            <a:off x="7269480" y="3383280"/>
             <a:ext cx="4160520" cy="274320"/>
           </a:xfrm>
           <a:prstGeom prst="rect">
@@ -10908,7 +10824,7 @@
               </a:spcAft>
             </a:pPr>
             <a:r>
-              <a:rPr sz="1300" b="1">
+              <a:rPr sz="1500" b="1">
                 <a:solidFill>
                   <a:srgbClr val="EDEDED"/>
                 </a:solidFill>
@@ -10927,7 +10843,7 @@
         </p:nvSpPr>
         <p:spPr>
           <a:xfrm>
-            <a:off x="7269480" y="3630168"/>
+            <a:off x="7269480" y="3730752"/>
             <a:ext cx="4160520" cy="548640"/>
           </a:xfrm>
           <a:prstGeom prst="rect">
@@ -10950,7 +10866,7 @@
               </a:spcAft>
             </a:pPr>
             <a:r>
-              <a:rPr sz="1000" b="0">
+              <a:rPr sz="1200" b="0">
                 <a:solidFill>
                   <a:srgbClr val="888888"/>
                 </a:solidFill>
@@ -10969,7 +10885,7 @@
         </p:nvSpPr>
         <p:spPr>
           <a:xfrm>
-            <a:off x="6858000" y="4206240"/>
+            <a:off x="6858000" y="4297680"/>
             <a:ext cx="457200" cy="274320"/>
           </a:xfrm>
           <a:prstGeom prst="rect">
@@ -10992,7 +10908,7 @@
               </a:spcAft>
             </a:pPr>
             <a:r>
-              <a:rPr sz="1100" b="1" spc="140">
+              <a:rPr sz="1200" b="1" spc="140">
                 <a:solidFill>
                   <a:srgbClr val="00D4FF"/>
                 </a:solidFill>
@@ -11011,7 +10927,7 @@
         </p:nvSpPr>
         <p:spPr>
           <a:xfrm>
-            <a:off x="7269480" y="4206240"/>
+            <a:off x="7269480" y="4297680"/>
             <a:ext cx="4160520" cy="274320"/>
           </a:xfrm>
           <a:prstGeom prst="rect">
@@ -11034,7 +10950,7 @@
               </a:spcAft>
             </a:pPr>
             <a:r>
-              <a:rPr sz="1300" b="1">
+              <a:rPr sz="1500" b="1">
                 <a:solidFill>
                   <a:srgbClr val="EDEDED"/>
                 </a:solidFill>
@@ -11053,7 +10969,7 @@
         </p:nvSpPr>
         <p:spPr>
           <a:xfrm>
-            <a:off x="7269480" y="4498848"/>
+            <a:off x="7269480" y="4645152"/>
             <a:ext cx="4160520" cy="548640"/>
           </a:xfrm>
           <a:prstGeom prst="rect">
@@ -11076,7 +10992,7 @@
               </a:spcAft>
             </a:pPr>
             <a:r>
-              <a:rPr sz="1000" b="0">
+              <a:rPr sz="1200" b="0">
                 <a:solidFill>
                   <a:srgbClr val="888888"/>
                 </a:solidFill>
@@ -11095,7 +11011,7 @@
         </p:nvSpPr>
         <p:spPr>
           <a:xfrm>
-            <a:off x="6858000" y="5074920"/>
+            <a:off x="6858000" y="5212080"/>
             <a:ext cx="457200" cy="274320"/>
           </a:xfrm>
           <a:prstGeom prst="rect">
@@ -11118,7 +11034,7 @@
               </a:spcAft>
             </a:pPr>
             <a:r>
-              <a:rPr sz="1100" b="1" spc="140">
+              <a:rPr sz="1200" b="1" spc="140">
                 <a:solidFill>
                   <a:srgbClr val="00D4FF"/>
                 </a:solidFill>
@@ -11137,7 +11053,7 @@
         </p:nvSpPr>
         <p:spPr>
           <a:xfrm>
-            <a:off x="7269480" y="5074920"/>
+            <a:off x="7269480" y="5212080"/>
             <a:ext cx="4160520" cy="274320"/>
           </a:xfrm>
           <a:prstGeom prst="rect">
@@ -11160,7 +11076,7 @@
               </a:spcAft>
             </a:pPr>
             <a:r>
-              <a:rPr sz="1300" b="1">
+              <a:rPr sz="1500" b="1">
                 <a:solidFill>
                   <a:srgbClr val="EDEDED"/>
                 </a:solidFill>
@@ -11179,7 +11095,7 @@
         </p:nvSpPr>
         <p:spPr>
           <a:xfrm>
-            <a:off x="7269480" y="5367528"/>
+            <a:off x="7269480" y="5559552"/>
             <a:ext cx="4160520" cy="548640"/>
           </a:xfrm>
           <a:prstGeom prst="rect">
@@ -11202,7 +11118,7 @@
               </a:spcAft>
             </a:pPr>
             <a:r>
-              <a:rPr sz="1000" b="0">
+              <a:rPr sz="1200" b="0">
                 <a:solidFill>
                   <a:srgbClr val="888888"/>
                 </a:solidFill>

</xml_diff>

<commit_message>
docs(presentation): fix grey text to white and bump body text sizes
Changed all 888888 body text to EDEDED (white) across all 8 slides.
Changed 666666 content text (>=10pt) to EDEDED on slides 6 and 8.
Increased body text: 10pt→12pt, 11pt→13pt, 12-13pt→14pt.

Co-Authored-By: Claude Sonnet 4.6 <noreply@anthropic.com>
</commit_message>
<xml_diff>
--- a/AI_Frontier_Presentation.pptx
+++ b/AI_Frontier_Presentation.pptx
@@ -3356,9 +3356,9 @@
               </a:spcAft>
             </a:pPr>
             <a:r>
-              <a:rPr sz="1000" b="1" spc="200">
-                <a:solidFill>
-                  <a:srgbClr val="666666"/>
+              <a:rPr sz="1200" b="1" spc="200">
+                <a:solidFill>
+                  <a:srgbClr val="EDEDED"/>
                 </a:solidFill>
                 <a:latin typeface="Inter"/>
               </a:rPr>
@@ -3442,7 +3442,7 @@
             <a:r>
               <a:rPr sz="2000" b="0">
                 <a:solidFill>
-                  <a:srgbClr val="888888"/>
+                  <a:srgbClr val="EDEDED"/>
                 </a:solidFill>
                 <a:latin typeface="Inter"/>
               </a:rPr>
@@ -3484,7 +3484,7 @@
             <a:r>
               <a:rPr sz="2000" b="0">
                 <a:solidFill>
-                  <a:srgbClr val="888888"/>
+                  <a:srgbClr val="EDEDED"/>
                 </a:solidFill>
                 <a:latin typeface="Inter"/>
               </a:rPr>
@@ -3895,9 +3895,9 @@
               </a:spcAft>
             </a:pPr>
             <a:r>
-              <a:rPr sz="1000" b="0">
-                <a:solidFill>
-                  <a:srgbClr val="666666"/>
+              <a:rPr sz="1200" b="0">
+                <a:solidFill>
+                  <a:srgbClr val="EDEDED"/>
                 </a:solidFill>
                 <a:latin typeface="Inter"/>
               </a:rPr>
@@ -4260,7 +4260,7 @@
             <a:r>
               <a:rPr sz="1400" b="0">
                 <a:solidFill>
-                  <a:srgbClr val="888888"/>
+                  <a:srgbClr val="EDEDED"/>
                 </a:solidFill>
                 <a:latin typeface="Inter"/>
               </a:rPr>
@@ -5311,7 +5311,7 @@
             <a:r>
               <a:rPr sz="1400" b="0">
                 <a:solidFill>
-                  <a:srgbClr val="888888"/>
+                  <a:srgbClr val="EDEDED"/>
                 </a:solidFill>
                 <a:latin typeface="Inter"/>
               </a:rPr>
@@ -5567,9 +5567,9 @@
               </a:spcAft>
             </a:pPr>
             <a:r>
-              <a:rPr sz="1100" b="0">
-                <a:solidFill>
-                  <a:srgbClr val="888888"/>
+              <a:rPr sz="1300" b="0">
+                <a:solidFill>
+                  <a:srgbClr val="EDEDED"/>
                 </a:solidFill>
                 <a:latin typeface="Inter"/>
               </a:rPr>
@@ -5653,9 +5653,9 @@
               </a:spcAft>
             </a:pPr>
             <a:r>
-              <a:rPr sz="1100" b="0">
-                <a:solidFill>
-                  <a:srgbClr val="888888"/>
+              <a:rPr sz="1300" b="0">
+                <a:solidFill>
+                  <a:srgbClr val="EDEDED"/>
                 </a:solidFill>
                 <a:latin typeface="Inter"/>
               </a:rPr>
@@ -5911,9 +5911,9 @@
               </a:spcAft>
             </a:pPr>
             <a:r>
-              <a:rPr sz="1100" b="0">
-                <a:solidFill>
-                  <a:srgbClr val="888888"/>
+              <a:rPr sz="1300" b="0">
+                <a:solidFill>
+                  <a:srgbClr val="EDEDED"/>
                 </a:solidFill>
                 <a:latin typeface="Inter"/>
               </a:rPr>
@@ -5997,9 +5997,9 @@
               </a:spcAft>
             </a:pPr>
             <a:r>
-              <a:rPr sz="1100" b="0">
-                <a:solidFill>
-                  <a:srgbClr val="888888"/>
+              <a:rPr sz="1300" b="0">
+                <a:solidFill>
+                  <a:srgbClr val="EDEDED"/>
                 </a:solidFill>
                 <a:latin typeface="Inter"/>
               </a:rPr>
@@ -6167,9 +6167,9 @@
               </a:spcAft>
             </a:pPr>
             <a:r>
-              <a:rPr sz="1100" b="0">
-                <a:solidFill>
-                  <a:srgbClr val="888888"/>
+              <a:rPr sz="1300" b="0">
+                <a:solidFill>
+                  <a:srgbClr val="EDEDED"/>
                 </a:solidFill>
                 <a:latin typeface="Inter"/>
               </a:rPr>
@@ -6286,9 +6286,9 @@
               </a:spcAft>
             </a:pPr>
             <a:r>
-              <a:rPr sz="1100" b="0">
-                <a:solidFill>
-                  <a:srgbClr val="888888"/>
+              <a:rPr sz="1300" b="0">
+                <a:solidFill>
+                  <a:srgbClr val="EDEDED"/>
                 </a:solidFill>
                 <a:latin typeface="Inter"/>
               </a:rPr>
@@ -6770,7 +6770,7 @@
             <a:r>
               <a:rPr sz="1400" b="0">
                 <a:solidFill>
-                  <a:srgbClr val="888888"/>
+                  <a:srgbClr val="EDEDED"/>
                 </a:solidFill>
                 <a:latin typeface="Inter"/>
               </a:rPr>
@@ -7024,9 +7024,9 @@
               </a:spcAft>
             </a:pPr>
             <a:r>
-              <a:rPr sz="1100" b="0">
-                <a:solidFill>
-                  <a:srgbClr val="888888"/>
+              <a:rPr sz="1300" b="0">
+                <a:solidFill>
+                  <a:srgbClr val="EDEDED"/>
                 </a:solidFill>
                 <a:latin typeface="Inter"/>
               </a:rPr>
@@ -7280,9 +7280,9 @@
               </a:spcAft>
             </a:pPr>
             <a:r>
-              <a:rPr sz="1100" b="0">
-                <a:solidFill>
-                  <a:srgbClr val="888888"/>
+              <a:rPr sz="1300" b="0">
+                <a:solidFill>
+                  <a:srgbClr val="EDEDED"/>
                 </a:solidFill>
                 <a:latin typeface="Inter"/>
               </a:rPr>
@@ -7536,9 +7536,9 @@
               </a:spcAft>
             </a:pPr>
             <a:r>
-              <a:rPr sz="1100" b="0">
-                <a:solidFill>
-                  <a:srgbClr val="888888"/>
+              <a:rPr sz="1300" b="0">
+                <a:solidFill>
+                  <a:srgbClr val="EDEDED"/>
                 </a:solidFill>
                 <a:latin typeface="Inter"/>
               </a:rPr>
@@ -7792,9 +7792,9 @@
               </a:spcAft>
             </a:pPr>
             <a:r>
-              <a:rPr sz="1100" b="0">
-                <a:solidFill>
-                  <a:srgbClr val="888888"/>
+              <a:rPr sz="1300" b="0">
+                <a:solidFill>
+                  <a:srgbClr val="EDEDED"/>
                 </a:solidFill>
                 <a:latin typeface="Inter"/>
               </a:rPr>
@@ -7920,9 +7920,9 @@
               </a:spcAft>
             </a:pPr>
             <a:r>
-              <a:rPr sz="1200" b="0">
-                <a:solidFill>
-                  <a:srgbClr val="888888"/>
+              <a:rPr sz="1400" b="0">
+                <a:solidFill>
+                  <a:srgbClr val="EDEDED"/>
                 </a:solidFill>
                 <a:latin typeface="Inter"/>
               </a:rPr>
@@ -8285,7 +8285,7 @@
             <a:r>
               <a:rPr sz="1400" b="0">
                 <a:solidFill>
-                  <a:srgbClr val="888888"/>
+                  <a:srgbClr val="EDEDED"/>
                 </a:solidFill>
                 <a:latin typeface="Inter"/>
               </a:rPr>
@@ -8497,9 +8497,9 @@
               </a:spcAft>
             </a:pPr>
             <a:r>
-              <a:rPr sz="1200" b="0">
-                <a:solidFill>
-                  <a:srgbClr val="888888"/>
+              <a:rPr sz="1400" b="0">
+                <a:solidFill>
+                  <a:srgbClr val="EDEDED"/>
                 </a:solidFill>
                 <a:latin typeface="Inter"/>
               </a:rPr>
@@ -8711,9 +8711,9 @@
               </a:spcAft>
             </a:pPr>
             <a:r>
-              <a:rPr sz="1200" b="0">
-                <a:solidFill>
-                  <a:srgbClr val="888888"/>
+              <a:rPr sz="1400" b="0">
+                <a:solidFill>
+                  <a:srgbClr val="EDEDED"/>
                 </a:solidFill>
                 <a:latin typeface="Inter"/>
               </a:rPr>
@@ -8925,9 +8925,9 @@
               </a:spcAft>
             </a:pPr>
             <a:r>
-              <a:rPr sz="1200" b="0">
-                <a:solidFill>
-                  <a:srgbClr val="888888"/>
+              <a:rPr sz="1400" b="0">
+                <a:solidFill>
+                  <a:srgbClr val="EDEDED"/>
                 </a:solidFill>
                 <a:latin typeface="Inter"/>
               </a:rPr>
@@ -9139,9 +9139,9 @@
               </a:spcAft>
             </a:pPr>
             <a:r>
-              <a:rPr sz="1200" b="0">
-                <a:solidFill>
-                  <a:srgbClr val="888888"/>
+              <a:rPr sz="1400" b="0">
+                <a:solidFill>
+                  <a:srgbClr val="EDEDED"/>
                 </a:solidFill>
                 <a:latin typeface="Inter"/>
               </a:rPr>
@@ -9353,9 +9353,9 @@
               </a:spcAft>
             </a:pPr>
             <a:r>
-              <a:rPr sz="1200" b="0">
-                <a:solidFill>
-                  <a:srgbClr val="888888"/>
+              <a:rPr sz="1400" b="0">
+                <a:solidFill>
+                  <a:srgbClr val="EDEDED"/>
                 </a:solidFill>
                 <a:latin typeface="Inter"/>
               </a:rPr>
@@ -9888,9 +9888,9 @@
               </a:spcAft>
             </a:pPr>
             <a:r>
-              <a:rPr sz="1200" b="0">
-                <a:solidFill>
-                  <a:srgbClr val="666666"/>
+              <a:rPr sz="1400" b="0">
+                <a:solidFill>
+                  <a:srgbClr val="EDEDED"/>
                 </a:solidFill>
                 <a:latin typeface="Inter"/>
               </a:rPr>
@@ -10016,9 +10016,9 @@
               </a:spcAft>
             </a:pPr>
             <a:r>
-              <a:rPr sz="1200" b="0">
-                <a:solidFill>
-                  <a:srgbClr val="666666"/>
+              <a:rPr sz="1400" b="0">
+                <a:solidFill>
+                  <a:srgbClr val="EDEDED"/>
                 </a:solidFill>
                 <a:latin typeface="Inter"/>
               </a:rPr>
@@ -10144,9 +10144,9 @@
               </a:spcAft>
             </a:pPr>
             <a:r>
-              <a:rPr sz="1200" b="0">
-                <a:solidFill>
-                  <a:srgbClr val="666666"/>
+              <a:rPr sz="1400" b="0">
+                <a:solidFill>
+                  <a:srgbClr val="EDEDED"/>
                 </a:solidFill>
                 <a:latin typeface="Inter"/>
               </a:rPr>
@@ -10272,9 +10272,9 @@
               </a:spcAft>
             </a:pPr>
             <a:r>
-              <a:rPr sz="1200" b="0">
-                <a:solidFill>
-                  <a:srgbClr val="666666"/>
+              <a:rPr sz="1400" b="0">
+                <a:solidFill>
+                  <a:srgbClr val="EDEDED"/>
                 </a:solidFill>
                 <a:latin typeface="Inter"/>
               </a:rPr>
@@ -10400,9 +10400,9 @@
               </a:spcAft>
             </a:pPr>
             <a:r>
-              <a:rPr sz="1200" b="0">
-                <a:solidFill>
-                  <a:srgbClr val="666666"/>
+              <a:rPr sz="1400" b="0">
+                <a:solidFill>
+                  <a:srgbClr val="EDEDED"/>
                 </a:solidFill>
                 <a:latin typeface="Inter"/>
               </a:rPr>
@@ -10528,9 +10528,9 @@
               </a:spcAft>
             </a:pPr>
             <a:r>
-              <a:rPr sz="1200" b="0">
-                <a:solidFill>
-                  <a:srgbClr val="666666"/>
+              <a:rPr sz="1400" b="0">
+                <a:solidFill>
+                  <a:srgbClr val="EDEDED"/>
                 </a:solidFill>
                 <a:latin typeface="Inter"/>
               </a:rPr>
@@ -10740,9 +10740,9 @@
               </a:spcAft>
             </a:pPr>
             <a:r>
-              <a:rPr sz="1200" b="0">
-                <a:solidFill>
-                  <a:srgbClr val="888888"/>
+              <a:rPr sz="1400" b="0">
+                <a:solidFill>
+                  <a:srgbClr val="EDEDED"/>
                 </a:solidFill>
                 <a:latin typeface="Inter"/>
               </a:rPr>
@@ -10866,9 +10866,9 @@
               </a:spcAft>
             </a:pPr>
             <a:r>
-              <a:rPr sz="1200" b="0">
-                <a:solidFill>
-                  <a:srgbClr val="888888"/>
+              <a:rPr sz="1400" b="0">
+                <a:solidFill>
+                  <a:srgbClr val="EDEDED"/>
                 </a:solidFill>
                 <a:latin typeface="Inter"/>
               </a:rPr>
@@ -10992,9 +10992,9 @@
               </a:spcAft>
             </a:pPr>
             <a:r>
-              <a:rPr sz="1200" b="0">
-                <a:solidFill>
-                  <a:srgbClr val="888888"/>
+              <a:rPr sz="1400" b="0">
+                <a:solidFill>
+                  <a:srgbClr val="EDEDED"/>
                 </a:solidFill>
                 <a:latin typeface="Inter"/>
               </a:rPr>
@@ -11118,9 +11118,9 @@
               </a:spcAft>
             </a:pPr>
             <a:r>
-              <a:rPr sz="1200" b="0">
-                <a:solidFill>
-                  <a:srgbClr val="888888"/>
+              <a:rPr sz="1400" b="0">
+                <a:solidFill>
+                  <a:srgbClr val="EDEDED"/>
                 </a:solidFill>
                 <a:latin typeface="Inter"/>
               </a:rPr>
@@ -11481,9 +11481,9 @@
               </a:spcAft>
             </a:pPr>
             <a:r>
-              <a:rPr sz="1300" b="0">
-                <a:solidFill>
-                  <a:srgbClr val="888888"/>
+              <a:rPr sz="1400" b="0">
+                <a:solidFill>
+                  <a:srgbClr val="EDEDED"/>
                 </a:solidFill>
                 <a:latin typeface="Inter"/>
               </a:rPr>
@@ -12295,9 +12295,9 @@
               </a:spcAft>
             </a:pPr>
             <a:r>
-              <a:rPr sz="1000" b="1">
-                <a:solidFill>
-                  <a:srgbClr val="888888"/>
+              <a:rPr sz="1200" b="1">
+                <a:solidFill>
+                  <a:srgbClr val="EDEDED"/>
                 </a:solidFill>
                 <a:latin typeface="Inter"/>
               </a:rPr>
@@ -12509,9 +12509,9 @@
               </a:spcAft>
             </a:pPr>
             <a:r>
-              <a:rPr sz="1000" b="1">
-                <a:solidFill>
-                  <a:srgbClr val="888888"/>
+              <a:rPr sz="1200" b="1">
+                <a:solidFill>
+                  <a:srgbClr val="EDEDED"/>
                 </a:solidFill>
                 <a:latin typeface="Inter"/>
               </a:rPr>
@@ -12723,9 +12723,9 @@
               </a:spcAft>
             </a:pPr>
             <a:r>
-              <a:rPr sz="1000" b="1">
-                <a:solidFill>
-                  <a:srgbClr val="888888"/>
+              <a:rPr sz="1200" b="1">
+                <a:solidFill>
+                  <a:srgbClr val="EDEDED"/>
                 </a:solidFill>
                 <a:latin typeface="Inter"/>
               </a:rPr>
@@ -13139,9 +13139,9 @@
               </a:spcAft>
             </a:pPr>
             <a:r>
-              <a:rPr sz="1000" b="0">
-                <a:solidFill>
-                  <a:srgbClr val="666666"/>
+              <a:rPr sz="1200" b="0">
+                <a:solidFill>
+                  <a:srgbClr val="EDEDED"/>
                 </a:solidFill>
                 <a:latin typeface="Inter"/>
               </a:rPr>
@@ -13311,9 +13311,9 @@
               </a:spcAft>
             </a:pPr>
             <a:r>
-              <a:rPr sz="1000" b="0">
-                <a:solidFill>
-                  <a:srgbClr val="666666"/>
+              <a:rPr sz="1200" b="0">
+                <a:solidFill>
+                  <a:srgbClr val="EDEDED"/>
                 </a:solidFill>
                 <a:latin typeface="Inter"/>
               </a:rPr>
@@ -13483,9 +13483,9 @@
               </a:spcAft>
             </a:pPr>
             <a:r>
-              <a:rPr sz="1000" b="0">
-                <a:solidFill>
-                  <a:srgbClr val="666666"/>
+              <a:rPr sz="1200" b="0">
+                <a:solidFill>
+                  <a:srgbClr val="EDEDED"/>
                 </a:solidFill>
                 <a:latin typeface="Inter"/>
               </a:rPr>
@@ -13655,9 +13655,9 @@
               </a:spcAft>
             </a:pPr>
             <a:r>
-              <a:rPr sz="1000" b="0">
-                <a:solidFill>
-                  <a:srgbClr val="666666"/>
+              <a:rPr sz="1200" b="0">
+                <a:solidFill>
+                  <a:srgbClr val="EDEDED"/>
                 </a:solidFill>
                 <a:latin typeface="Inter"/>
               </a:rPr>
@@ -13827,9 +13827,9 @@
               </a:spcAft>
             </a:pPr>
             <a:r>
-              <a:rPr sz="1000" b="0">
-                <a:solidFill>
-                  <a:srgbClr val="666666"/>
+              <a:rPr sz="1200" b="0">
+                <a:solidFill>
+                  <a:srgbClr val="EDEDED"/>
                 </a:solidFill>
                 <a:latin typeface="Inter"/>
               </a:rPr>
@@ -13946,9 +13946,9 @@
               </a:spcAft>
             </a:pPr>
             <a:r>
-              <a:rPr sz="1000" b="0">
-                <a:solidFill>
-                  <a:srgbClr val="888888"/>
+              <a:rPr sz="1200" b="0">
+                <a:solidFill>
+                  <a:srgbClr val="EDEDED"/>
                 </a:solidFill>
                 <a:latin typeface="Inter"/>
               </a:rPr>
@@ -14030,9 +14030,9 @@
               </a:spcAft>
             </a:pPr>
             <a:r>
-              <a:rPr sz="1000" b="0">
-                <a:solidFill>
-                  <a:srgbClr val="888888"/>
+              <a:rPr sz="1200" b="0">
+                <a:solidFill>
+                  <a:srgbClr val="EDEDED"/>
                 </a:solidFill>
                 <a:latin typeface="Inter"/>
               </a:rPr>

</xml_diff>

<commit_message>
docs: replace localhost with live Render URL in report and presentation
Co-Authored-By: Claude Sonnet 4.6 <noreply@anthropic.com>
</commit_message>
<xml_diff>
--- a/AI_Frontier_Presentation.pptx
+++ b/AI_Frontier_Presentation.pptx
@@ -5993,13 +5993,13 @@
               </a:spcAft>
             </a:pPr>
             <a:r>
-              <a:rPr sz="2400" b="1">
+              <a:rPr sz="2000" b="1">
                 <a:solidFill>
                   <a:srgbClr val="00D4FF"/>
                 </a:solidFill>
                 <a:latin typeface="Inter"/>
               </a:rPr>
-              <a:t>→ localhost:8050</a:t>
+              <a:t>→ ai-frontier-database.onrender.com</a:t>
             </a:r>
           </a:p>
         </p:txBody>

</xml_diff>